<commit_message>
Apply Vibra Energia colors to Suzano deck and drop pump price
Co-Authored-By: Claude Sonnet 5.5 <noreply@anthropic.com>
Claude-Session: https://claude.ai/code/session_01VxfJJiuGCU6eSExawmMqse
</commit_message>
<xml_diff>
--- a/Diesel_Cenarios_Hedge_Suzano_2026-10-06.pptx
+++ b/Diesel_Cenarios_Hedge_Suzano_2026-10-06.pptx
@@ -119,13 +119,13 @@
   <p:extLst>
     <p:ext uri="{521415D9-36F7-43E2-AB2F-B90AF26B5E84}">
       <p14:sectionLst xmlns:p14="http://schemas.microsoft.com/office/powerpoint/2010/main">
-        <p14:section name="Abertura" id="{cb7bd044-955c-f3d7-0703-99334040b2dd}">
+        <p14:section name="Abertura" id="{3c879b43-ee92-8739-3c2f-f93f282809b5}">
           <p14:sldIdLst>
             <p14:sldId id="256"/>
             <p14:sldId id="257"/>
           </p14:sldIdLst>
         </p14:section>
-        <p14:section name="Cenários" id="{ac396498-2c1d-3a01-31fd-233d8ca48fb7}">
+        <p14:section name="Cenários" id="{c77a5c2e-84db-d9dd-121e-40e71a2e81b1}">
           <p14:sldIdLst>
             <p14:sldId id="258"/>
             <p14:sldId id="259"/>
@@ -133,7 +133,7 @@
             <p14:sldId id="261"/>
           </p14:sldIdLst>
         </p14:section>
-        <p14:section name="Hedge" id="{a8438e00-3876-1d9a-00e9-015c7f080130}">
+        <p14:section name="Hedge" id="{963538b1-6c15-c8f0-9047-336363bf998d}">
           <p14:sldIdLst>
             <p14:sldId id="262"/>
             <p14:sldId id="263"/>
@@ -142,7 +142,7 @@
             <p14:sldId id="266"/>
           </p14:sldIdLst>
         </p14:section>
-        <p14:section name="Apoio" id="{f3a98e73-98e6-e1af-53ff-fadd56a73228}">
+        <p14:section name="Apoio" id="{68bcfc25-4f09-630e-c4fc-0a1b0df89ab4}">
           <p14:sldIdLst>
             <p14:sldId id="267"/>
             <p14:sldId id="268"/>
@@ -257,7 +257,7 @@
           </c:tx>
           <c:spPr>
             <a:solidFill>
-              <a:srgbClr val="C75A0B"/>
+              <a:srgbClr val="00873A"/>
             </a:solidFill>
             <a:effectLst/>
           </c:spPr>
@@ -443,7 +443,7 @@
             <a:pPr>
               <a:defRPr sz="1400" b="0" i="0" u="none" strike="noStrike">
                 <a:solidFill>
-                  <a:srgbClr val="1B1F23"/>
+                  <a:srgbClr val="17211C"/>
                 </a:solidFill>
                 <a:latin typeface="Calibri"/>
               </a:defRPr>
@@ -557,7 +557,7 @@
           <a:pPr>
             <a:defRPr sz="1400">
               <a:solidFill>
-                <a:srgbClr val="1B1F23"/>
+                <a:srgbClr val="17211C"/>
               </a:solidFill>
               <a:latin typeface="Calibri"/>
               <a:cs typeface="Calibri"/>
@@ -604,14 +604,14 @@
               <c:strCache>
                 <c:ptCount val="1"/>
                 <c:pt idx="0">
-                  <c:v>Distribuidor (diesel A, refinaria)</c:v>
+                  <c:v>Preço ao distribuidor (diesel A)</c:v>
                 </c:pt>
               </c:strCache>
             </c:strRef>
           </c:tx>
           <c:spPr>
             <a:solidFill>
-              <a:srgbClr val="C75A0B"/>
+              <a:srgbClr val="00873A"/>
             </a:solidFill>
             <a:effectLst/>
           </c:spPr>
@@ -625,7 +625,7 @@
                 <a:pPr>
                   <a:defRPr b="1" i="0" strike="noStrike" sz="1400" u="none">
                     <a:solidFill>
-                      <a:srgbClr val="1B1F23"/>
+                      <a:srgbClr val="17211C"/>
                     </a:solidFill>
                     <a:latin typeface="Calibri"/>
                   </a:defRPr>
@@ -690,101 +690,6 @@
             </c:numRef>
           </c:val>
         </c:ser>
-        <c:ser>
-          <c:idx val="1"/>
-          <c:order val="1"/>
-          <c:tx>
-            <c:strRef>
-              <c:f>Sheet1!$C$1</c:f>
-              <c:strCache>
-                <c:ptCount val="1"/>
-                <c:pt idx="0">
-                  <c:v>Bomba (S-10, ponto central)</c:v>
-                </c:pt>
-              </c:strCache>
-            </c:strRef>
-          </c:tx>
-          <c:spPr>
-            <a:solidFill>
-              <a:srgbClr val="4A5A66"/>
-            </a:solidFill>
-            <a:effectLst/>
-          </c:spPr>
-          <c:invertIfNegative val="0"/>
-          <c:dLbls>
-            <c:numFmt formatCode="0.00" sourceLinked="0"/>
-            <c:txPr>
-              <a:bodyPr/>
-              <a:lstStyle/>
-              <a:p>
-                <a:pPr>
-                  <a:defRPr b="1" i="0" strike="noStrike" sz="1400" u="none">
-                    <a:solidFill>
-                      <a:srgbClr val="1B1F23"/>
-                    </a:solidFill>
-                    <a:latin typeface="Calibri"/>
-                  </a:defRPr>
-                </a:pPr>
-              </a:p>
-            </c:txPr>
-            <c:showLegendKey val="0"/>
-            <c:showVal val="1"/>
-            <c:showCatName val="0"/>
-            <c:showSerName val="0"/>
-            <c:showPercent val="0"/>
-            <c:showBubbleSize val="0"/>
-            <c:showLeaderLines val="0"/>
-          </c:dLbls>
-          <c:cat>
-            <c:multiLvlStrRef>
-              <c:f>Sheet1!$A$2:$A$6</c:f>
-              <c:multiLvlStrCache>
-                <c:ptCount val="5"/>
-                <c:lvl>
-                  <c:pt idx="0">
-                    <c:v>1. Desescalada</c:v>
-                  </c:pt>
-                  <c:pt idx="1">
-                    <c:v>2. Status quo</c:v>
-                  </c:pt>
-                  <c:pt idx="2">
-                    <c:v>3. Parcial</c:v>
-                  </c:pt>
-                  <c:pt idx="3">
-                    <c:v>4. Fim total</c:v>
-                  </c:pt>
-                  <c:pt idx="4">
-                    <c:v>Teto</c:v>
-                  </c:pt>
-                </c:lvl>
-              </c:multiLvlStrCache>
-            </c:multiLvlStrRef>
-          </c:cat>
-          <c:val>
-            <c:numRef>
-              <c:f>Sheet1!$C$2:$C$6</c:f>
-              <c:numCache>
-                <c:formatCode>General</c:formatCode>
-                <c:ptCount val="5"/>
-                <c:pt idx="0">
-                  <c:v>7.25</c:v>
-                </c:pt>
-                <c:pt idx="1">
-                  <c:v>7.4</c:v>
-                </c:pt>
-                <c:pt idx="2">
-                  <c:v>8.2</c:v>
-                </c:pt>
-                <c:pt idx="3">
-                  <c:v>9.15</c:v>
-                </c:pt>
-                <c:pt idx="4">
-                  <c:v>10.2</c:v>
-                </c:pt>
-              </c:numCache>
-            </c:numRef>
-          </c:val>
-        </c:ser>
         <c:dLbls>
           <c:numFmt formatCode="0.00" sourceLinked="0"/>
           <c:txPr>
@@ -794,7 +699,7 @@
               <a:pPr>
                 <a:defRPr b="1" i="0" strike="noStrike" sz="1400" u="none">
                   <a:solidFill>
-                    <a:srgbClr val="1B1F23"/>
+                    <a:srgbClr val="17211C"/>
                   </a:solidFill>
                   <a:latin typeface="Calibri"/>
                 </a:defRPr>
@@ -809,7 +714,7 @@
           <c:showBubbleSize val="0"/>
           <c:showLeaderLines val="0"/>
         </c:dLbls>
-        <c:gapWidth val="70"/>
+        <c:gapWidth val="80"/>
         <c:overlap val="0"/>
         <c:axId val="2094734554"/>
         <c:axId val="2094734552"/>
@@ -842,7 +747,7 @@
             <a:pPr>
               <a:defRPr sz="1400" b="0" i="0" u="none" strike="noStrike">
                 <a:solidFill>
-                  <a:srgbClr val="1B1F23"/>
+                  <a:srgbClr val="17211C"/>
                 </a:solidFill>
                 <a:latin typeface="Calibri"/>
               </a:defRPr>
@@ -860,7 +765,7 @@
         <c:axId val="2094734552"/>
         <c:scaling>
           <c:orientation val="minMax"/>
-          <c:max val="12"/>
+          <c:max val="8"/>
           <c:min val="0"/>
         </c:scaling>
         <c:delete val="0"/>
@@ -897,7 +802,7 @@
                     </a:solidFill>
                     <a:latin typeface="Arial"/>
                   </a:rPr>
-                  <a:t>R$ por litro</a:t>
+                  <a:t>R$ por litro de diesel A</a:t>
                 </a:r>
               </a:p>
             </c:rich>
@@ -946,26 +851,6 @@
         <a:effectLst/>
       </c:spPr>
     </c:plotArea>
-    <c:legend>
-      <c:legendPos val="t"/>
-      <c:overlay val="0"/>
-      <c:txPr>
-        <a:bodyPr/>
-        <a:lstStyle/>
-        <a:p>
-          <a:pPr>
-            <a:defRPr sz="1400">
-              <a:solidFill>
-                <a:srgbClr val="1B1F23"/>
-              </a:solidFill>
-              <a:latin typeface="Calibri"/>
-              <a:cs typeface="Calibri"/>
-            </a:defRPr>
-          </a:pPr>
-          <a:endParaRPr lang="en-US"/>
-        </a:p>
-      </c:txPr>
-    </c:legend>
     <c:plotVisOnly val="1"/>
     <c:dispBlanksAs val="span"/>
   </c:chart>
@@ -1010,7 +895,7 @@
           </c:tx>
           <c:spPr>
             <a:solidFill>
-              <a:srgbClr val="C75A0B"/>
+              <a:srgbClr val="00873A"/>
             </a:solidFill>
             <a:effectLst/>
           </c:spPr>
@@ -1024,7 +909,7 @@
                 <a:pPr>
                   <a:defRPr b="1" i="0" strike="noStrike" sz="1400" u="none">
                     <a:solidFill>
-                      <a:srgbClr val="1B1F23"/>
+                      <a:srgbClr val="17211C"/>
                     </a:solidFill>
                     <a:latin typeface="Calibri"/>
                   </a:defRPr>
@@ -1086,7 +971,7 @@
               <a:pPr>
                 <a:defRPr b="1" i="0" strike="noStrike" sz="1400" u="none">
                   <a:solidFill>
-                    <a:srgbClr val="1B1F23"/>
+                    <a:srgbClr val="17211C"/>
                   </a:solidFill>
                   <a:latin typeface="Calibri"/>
                 </a:defRPr>
@@ -1134,7 +1019,7 @@
             <a:pPr>
               <a:defRPr sz="1200" b="0" i="0" u="none" strike="noStrike">
                 <a:solidFill>
-                  <a:srgbClr val="1B1F23"/>
+                  <a:srgbClr val="17211C"/>
                 </a:solidFill>
                 <a:latin typeface="Calibri"/>
               </a:defRPr>
@@ -1296,7 +1181,7 @@
                 <a:pPr>
                   <a:defRPr b="1" i="0" strike="noStrike" sz="1200" u="none">
                     <a:solidFill>
-                      <a:srgbClr val="1B1F23"/>
+                      <a:srgbClr val="17211C"/>
                     </a:solidFill>
                     <a:latin typeface="Calibri"/>
                   </a:defRPr>
@@ -1377,7 +1262,7 @@
           </c:tx>
           <c:spPr>
             <a:solidFill>
-              <a:srgbClr val="1F6F6B"/>
+              <a:srgbClr val="00873A"/>
             </a:solidFill>
             <a:effectLst/>
           </c:spPr>
@@ -1391,7 +1276,7 @@
                 <a:pPr>
                   <a:defRPr b="1" i="0" strike="noStrike" sz="1200" u="none">
                     <a:solidFill>
-                      <a:srgbClr val="1B1F23"/>
+                      <a:srgbClr val="17211C"/>
                     </a:solidFill>
                     <a:latin typeface="Calibri"/>
                   </a:defRPr>
@@ -1465,7 +1350,7 @@
               <a:pPr>
                 <a:defRPr b="1" i="0" strike="noStrike" sz="1200" u="none">
                   <a:solidFill>
-                    <a:srgbClr val="1B1F23"/>
+                    <a:srgbClr val="17211C"/>
                   </a:solidFill>
                   <a:latin typeface="Calibri"/>
                 </a:defRPr>
@@ -1513,7 +1398,7 @@
             <a:pPr>
               <a:defRPr sz="1200" b="0" i="0" u="none" strike="noStrike">
                 <a:solidFill>
-                  <a:srgbClr val="1B1F23"/>
+                  <a:srgbClr val="17211C"/>
                 </a:solidFill>
                 <a:latin typeface="Calibri"/>
               </a:defRPr>
@@ -1627,7 +1512,7 @@
           <a:pPr>
             <a:defRPr sz="1400">
               <a:solidFill>
-                <a:srgbClr val="1B1F23"/>
+                <a:srgbClr val="17211C"/>
               </a:solidFill>
               <a:latin typeface="Calibri"/>
               <a:cs typeface="Calibri"/>
@@ -2488,7 +2373,7 @@
           <a:p>
             <a:r>
               <a:rPr lang="en-US" dirty="0"/>
-              <a:t>Três números para abrir: R$ 2,12 de subvenção, R$ 3,27 de defasagem e a faixa de R$ 9 a 10 na bomba. A mensagem: o risco de dezembro é político e de mercado ao mesmo tempo; só a parte de mercado é hedgeável.</a:t>
+              <a:t>Três números para abrir: R$ 2,12 de subvenção, R$ 3,27 de defasagem e a faixa de R$ 5,42 a 6,65 por litro ao distribuidor se a subvenção acabar. A mensagem: o risco de dezembro é político e de mercado ao mesmo tempo; só a parte de mercado é hedgeável.</a:t>
             </a:r>
             <a:endParaRPr lang="en-US" dirty="0"/>
           </a:p>
@@ -2752,7 +2637,7 @@
           <a:p>
             <a:r>
               <a:rPr lang="en-US" dirty="0"/>
-              <a:t>Pontos centrais das faixas da tabela. Variação na bomba = 85% da variação na refinaria.</a:t>
+              <a:t>Preço ao distribuidor de diesel A em cada cenário; o teto usa a paridade de importação de hoje.</a:t>
             </a:r>
             <a:endParaRPr lang="en-US" dirty="0"/>
           </a:p>
@@ -3182,7 +3067,7 @@
     <p:bg>
       <p:bgPr>
         <a:solidFill>
-          <a:srgbClr val="26333D"/>
+          <a:srgbClr val="0B3B2A"/>
         </a:solidFill>
       </p:bgPr>
     </p:bg>
@@ -3342,7 +3227,7 @@
               <a:buNone/>
               <a:defRPr lang="en-US" sz="3200" b="1" dirty="0">
                 <a:solidFill>
-                  <a:srgbClr val="1B1F23"/>
+                  <a:srgbClr val="17211C"/>
                 </a:solidFill>
                 <a:latin typeface="Cambria" pitchFamily="34" charset="0"/>
                 <a:ea typeface="Cambria" pitchFamily="34" charset="-122"/>
@@ -3799,7 +3684,57 @@
       </p:grpSpPr>
       <p:sp>
         <p:nvSpPr>
-          <p:cNvPr id="2" name="Text 0"/>
+          <p:cNvPr id="2" name="motif-yellow"/>
+          <p:cNvSpPr/>
+          <p:nvPr/>
+        </p:nvSpPr>
+        <p:spPr>
+          <a:xfrm>
+            <a:off x="9509760" y="4297680"/>
+            <a:ext cx="4206240" cy="4206240"/>
+          </a:xfrm>
+          <a:prstGeom prst="ellipse">
+            <a:avLst/>
+          </a:prstGeom>
+          <a:solidFill>
+            <a:srgbClr val="FFCB05"/>
+          </a:solidFill>
+          <a:ln w="12700">
+            <a:solidFill>
+              <a:srgbClr val="FFCB05"/>
+            </a:solidFill>
+            <a:prstDash val="solid"/>
+          </a:ln>
+        </p:spPr>
+      </p:sp>
+      <p:sp>
+        <p:nvSpPr>
+          <p:cNvPr id="3" name="motif-green"/>
+          <p:cNvSpPr/>
+          <p:nvPr/>
+        </p:nvSpPr>
+        <p:spPr>
+          <a:xfrm>
+            <a:off x="8412480" y="5120640"/>
+            <a:ext cx="2926080" cy="2926080"/>
+          </a:xfrm>
+          <a:prstGeom prst="ellipse">
+            <a:avLst/>
+          </a:prstGeom>
+          <a:solidFill>
+            <a:srgbClr val="00A859"/>
+          </a:solidFill>
+          <a:ln w="12700">
+            <a:solidFill>
+              <a:srgbClr val="00A859"/>
+            </a:solidFill>
+            <a:prstDash val="solid"/>
+          </a:ln>
+        </p:spPr>
+      </p:sp>
+      <p:sp>
+        <p:nvSpPr>
+          <p:cNvPr id="4" name="Text 0"/>
           <p:cNvSpPr/>
           <p:nvPr>
             <p:ph idx="100" type="title" hasCustomPrompt="1"/>
@@ -3840,7 +3775,7 @@
       </p:sp>
       <p:sp>
         <p:nvSpPr>
-          <p:cNvPr id="3" name="Text 0"/>
+          <p:cNvPr id="5" name="Text 0"/>
           <p:cNvSpPr/>
           <p:nvPr>
             <p:ph idx="101" type="body" hasCustomPrompt="1"/>
@@ -3933,7 +3868,7 @@
             <a:r>
               <a:rPr lang="en-US" sz="3200" b="1" dirty="0">
                 <a:solidFill>
-                  <a:srgbClr val="1B1F23"/>
+                  <a:srgbClr val="17211C"/>
                 </a:solidFill>
                 <a:latin typeface="Cambria" pitchFamily="34" charset="0"/>
                 <a:ea typeface="Cambria" pitchFamily="34" charset="-122"/>
@@ -3962,11 +3897,11 @@
             </a:avLst>
           </a:prstGeom>
           <a:solidFill>
-            <a:srgbClr val="EEF0F1"/>
+            <a:srgbClr val="EDF2EE"/>
           </a:solidFill>
           <a:ln w="12700">
             <a:solidFill>
-              <a:srgbClr val="EEF0F1"/>
+              <a:srgbClr val="EDF2EE"/>
             </a:solidFill>
             <a:prstDash val="solid"/>
           </a:ln>
@@ -3999,7 +3934,7 @@
             <a:r>
               <a:rPr lang="en-US" sz="2200" b="1" dirty="0">
                 <a:solidFill>
-                  <a:srgbClr val="1F6F6B"/>
+                  <a:srgbClr val="0B5D3B"/>
                 </a:solidFill>
                 <a:latin typeface="Cambria" pitchFamily="34" charset="0"/>
                 <a:ea typeface="Cambria" pitchFamily="34" charset="-122"/>
@@ -4042,7 +3977,7 @@
             <a:r>
               <a:rPr lang="en-US" sz="1800" dirty="0">
                 <a:solidFill>
-                  <a:srgbClr val="1B1F23"/>
+                  <a:srgbClr val="17211C"/>
                 </a:solidFill>
                 <a:latin typeface="Calibri" pitchFamily="34" charset="0"/>
                 <a:ea typeface="Calibri" pitchFamily="34" charset="-122"/>
@@ -4063,7 +3998,7 @@
             <a:r>
               <a:rPr lang="en-US" sz="1800" dirty="0">
                 <a:solidFill>
-                  <a:srgbClr val="1B1F23"/>
+                  <a:srgbClr val="17211C"/>
                 </a:solidFill>
                 <a:latin typeface="Calibri" pitchFamily="34" charset="0"/>
                 <a:ea typeface="Calibri" pitchFamily="34" charset="-122"/>
@@ -4084,7 +4019,7 @@
             <a:r>
               <a:rPr lang="en-US" sz="1800" dirty="0">
                 <a:solidFill>
-                  <a:srgbClr val="1B1F23"/>
+                  <a:srgbClr val="17211C"/>
                 </a:solidFill>
                 <a:latin typeface="Calibri" pitchFamily="34" charset="0"/>
                 <a:ea typeface="Calibri" pitchFamily="34" charset="-122"/>
@@ -4105,7 +4040,7 @@
             <a:r>
               <a:rPr lang="en-US" sz="1800" dirty="0">
                 <a:solidFill>
-                  <a:srgbClr val="1B1F23"/>
+                  <a:srgbClr val="17211C"/>
                 </a:solidFill>
                 <a:latin typeface="Calibri" pitchFamily="34" charset="0"/>
                 <a:ea typeface="Calibri" pitchFamily="34" charset="-122"/>
@@ -4134,11 +4069,11 @@
             </a:avLst>
           </a:prstGeom>
           <a:solidFill>
-            <a:srgbClr val="EEF0F1"/>
+            <a:srgbClr val="EDF2EE"/>
           </a:solidFill>
           <a:ln w="12700">
             <a:solidFill>
-              <a:srgbClr val="EEF0F1"/>
+              <a:srgbClr val="EDF2EE"/>
             </a:solidFill>
             <a:prstDash val="solid"/>
           </a:ln>
@@ -4214,7 +4149,7 @@
             <a:r>
               <a:rPr lang="en-US" sz="1800" dirty="0">
                 <a:solidFill>
-                  <a:srgbClr val="1B1F23"/>
+                  <a:srgbClr val="17211C"/>
                 </a:solidFill>
                 <a:latin typeface="Calibri" pitchFamily="34" charset="0"/>
                 <a:ea typeface="Calibri" pitchFamily="34" charset="-122"/>
@@ -4235,7 +4170,7 @@
             <a:r>
               <a:rPr lang="en-US" sz="1800" dirty="0">
                 <a:solidFill>
-                  <a:srgbClr val="1B1F23"/>
+                  <a:srgbClr val="17211C"/>
                 </a:solidFill>
                 <a:latin typeface="Calibri" pitchFamily="34" charset="0"/>
                 <a:ea typeface="Calibri" pitchFamily="34" charset="-122"/>
@@ -4256,7 +4191,7 @@
             <a:r>
               <a:rPr lang="en-US" sz="1800" dirty="0">
                 <a:solidFill>
-                  <a:srgbClr val="1B1F23"/>
+                  <a:srgbClr val="17211C"/>
                 </a:solidFill>
                 <a:latin typeface="Calibri" pitchFamily="34" charset="0"/>
                 <a:ea typeface="Calibri" pitchFamily="34" charset="-122"/>
@@ -4277,7 +4212,7 @@
             <a:r>
               <a:rPr lang="en-US" sz="1800" dirty="0">
                 <a:solidFill>
-                  <a:srgbClr val="1B1F23"/>
+                  <a:srgbClr val="17211C"/>
                 </a:solidFill>
                 <a:latin typeface="Calibri" pitchFamily="34" charset="0"/>
                 <a:ea typeface="Calibri" pitchFamily="34" charset="-122"/>
@@ -4391,7 +4326,7 @@
             <a:r>
               <a:rPr lang="en-US" sz="3200" b="1" dirty="0">
                 <a:solidFill>
-                  <a:srgbClr val="1B1F23"/>
+                  <a:srgbClr val="17211C"/>
                 </a:solidFill>
                 <a:latin typeface="Cambria" pitchFamily="34" charset="0"/>
                 <a:ea typeface="Cambria" pitchFamily="34" charset="-122"/>
@@ -4420,11 +4355,11 @@
             </a:avLst>
           </a:prstGeom>
           <a:solidFill>
-            <a:srgbClr val="EEF0F1"/>
+            <a:srgbClr val="EDF2EE"/>
           </a:solidFill>
           <a:ln w="12700">
             <a:solidFill>
-              <a:srgbClr val="EEF0F1"/>
+              <a:srgbClr val="EDF2EE"/>
             </a:solidFill>
             <a:prstDash val="solid"/>
           </a:ln>
@@ -4445,11 +4380,11 @@
             <a:avLst/>
           </a:prstGeom>
           <a:solidFill>
-            <a:srgbClr val="C75A0B"/>
+            <a:srgbClr val="00873A"/>
           </a:solidFill>
           <a:ln w="12700">
             <a:solidFill>
-              <a:srgbClr val="C75A0B"/>
+              <a:srgbClr val="00873A"/>
             </a:solidFill>
             <a:prstDash val="solid"/>
           </a:ln>
@@ -4521,7 +4456,7 @@
             <a:r>
               <a:rPr lang="en-US" sz="2000" b="1" dirty="0">
                 <a:solidFill>
-                  <a:srgbClr val="1B1F23"/>
+                  <a:srgbClr val="17211C"/>
                 </a:solidFill>
                 <a:latin typeface="Cambria" pitchFamily="34" charset="0"/>
                 <a:ea typeface="Cambria" pitchFamily="34" charset="-122"/>
@@ -4560,7 +4495,7 @@
             <a:r>
               <a:rPr lang="en-US" sz="1800" dirty="0">
                 <a:solidFill>
-                  <a:srgbClr val="1B1F23"/>
+                  <a:srgbClr val="17211C"/>
                 </a:solidFill>
                 <a:latin typeface="Calibri" pitchFamily="34" charset="0"/>
                 <a:ea typeface="Calibri" pitchFamily="34" charset="-122"/>
@@ -4589,11 +4524,11 @@
             </a:avLst>
           </a:prstGeom>
           <a:solidFill>
-            <a:srgbClr val="EEF0F1"/>
+            <a:srgbClr val="EDF2EE"/>
           </a:solidFill>
           <a:ln w="12700">
             <a:solidFill>
-              <a:srgbClr val="EEF0F1"/>
+              <a:srgbClr val="EDF2EE"/>
             </a:solidFill>
             <a:prstDash val="solid"/>
           </a:ln>
@@ -4614,11 +4549,11 @@
             <a:avLst/>
           </a:prstGeom>
           <a:solidFill>
-            <a:srgbClr val="C75A0B"/>
+            <a:srgbClr val="00873A"/>
           </a:solidFill>
           <a:ln w="12700">
             <a:solidFill>
-              <a:srgbClr val="C75A0B"/>
+              <a:srgbClr val="00873A"/>
             </a:solidFill>
             <a:prstDash val="solid"/>
           </a:ln>
@@ -4690,7 +4625,7 @@
             <a:r>
               <a:rPr lang="en-US" sz="2000" b="1" dirty="0">
                 <a:solidFill>
-                  <a:srgbClr val="1B1F23"/>
+                  <a:srgbClr val="17211C"/>
                 </a:solidFill>
                 <a:latin typeface="Cambria" pitchFamily="34" charset="0"/>
                 <a:ea typeface="Cambria" pitchFamily="34" charset="-122"/>
@@ -4729,7 +4664,7 @@
             <a:r>
               <a:rPr lang="en-US" sz="1800" dirty="0">
                 <a:solidFill>
-                  <a:srgbClr val="1B1F23"/>
+                  <a:srgbClr val="17211C"/>
                 </a:solidFill>
                 <a:latin typeface="Calibri" pitchFamily="34" charset="0"/>
                 <a:ea typeface="Calibri" pitchFamily="34" charset="-122"/>
@@ -4758,11 +4693,11 @@
             </a:avLst>
           </a:prstGeom>
           <a:solidFill>
-            <a:srgbClr val="EEF0F1"/>
+            <a:srgbClr val="EDF2EE"/>
           </a:solidFill>
           <a:ln w="12700">
             <a:solidFill>
-              <a:srgbClr val="EEF0F1"/>
+              <a:srgbClr val="EDF2EE"/>
             </a:solidFill>
             <a:prstDash val="solid"/>
           </a:ln>
@@ -4783,11 +4718,11 @@
             <a:avLst/>
           </a:prstGeom>
           <a:solidFill>
-            <a:srgbClr val="C75A0B"/>
+            <a:srgbClr val="00873A"/>
           </a:solidFill>
           <a:ln w="12700">
             <a:solidFill>
-              <a:srgbClr val="C75A0B"/>
+              <a:srgbClr val="00873A"/>
             </a:solidFill>
             <a:prstDash val="solid"/>
           </a:ln>
@@ -4859,7 +4794,7 @@
             <a:r>
               <a:rPr lang="en-US" sz="2000" b="1" dirty="0">
                 <a:solidFill>
-                  <a:srgbClr val="1B1F23"/>
+                  <a:srgbClr val="17211C"/>
                 </a:solidFill>
                 <a:latin typeface="Cambria" pitchFamily="34" charset="0"/>
                 <a:ea typeface="Cambria" pitchFamily="34" charset="-122"/>
@@ -4898,7 +4833,7 @@
             <a:r>
               <a:rPr lang="en-US" sz="1800" dirty="0">
                 <a:solidFill>
-                  <a:srgbClr val="1B1F23"/>
+                  <a:srgbClr val="17211C"/>
                 </a:solidFill>
                 <a:latin typeface="Calibri" pitchFamily="34" charset="0"/>
                 <a:ea typeface="Calibri" pitchFamily="34" charset="-122"/>
@@ -4927,11 +4862,11 @@
             </a:avLst>
           </a:prstGeom>
           <a:solidFill>
-            <a:srgbClr val="26333D"/>
+            <a:srgbClr val="0B3B2A"/>
           </a:solidFill>
           <a:ln w="12700">
             <a:solidFill>
-              <a:srgbClr val="26333D"/>
+              <a:srgbClr val="0B3B2A"/>
             </a:solidFill>
             <a:prstDash val="solid"/>
           </a:ln>
@@ -4967,7 +4902,7 @@
             <a:r>
               <a:rPr lang="en-US" sz="1800" b="1" dirty="0">
                 <a:solidFill>
-                  <a:srgbClr val="E9B44C"/>
+                  <a:srgbClr val="FFCB05"/>
                 </a:solidFill>
                 <a:latin typeface="Calibri" pitchFamily="34" charset="0"/>
                 <a:ea typeface="Calibri" pitchFamily="34" charset="-122"/>
@@ -5098,7 +5033,7 @@
             <a:r>
               <a:rPr lang="en-US" sz="3200" b="1" dirty="0">
                 <a:solidFill>
-                  <a:srgbClr val="1B1F23"/>
+                  <a:srgbClr val="17211C"/>
                 </a:solidFill>
                 <a:latin typeface="Cambria" pitchFamily="34" charset="0"/>
                 <a:ea typeface="Cambria" pitchFamily="34" charset="-122"/>
@@ -5194,7 +5129,7 @@
                       <a:tailEnd type="none" w="med" len="med"/>
                     </a:lnB>
                     <a:solidFill>
-                      <a:srgbClr val="26333D"/>
+                      <a:srgbClr val="0B3B2A"/>
                     </a:solidFill>
                   </a:tcPr>
                 </a:tc>
@@ -5255,7 +5190,7 @@
                       <a:tailEnd type="none" w="med" len="med"/>
                     </a:lnB>
                     <a:solidFill>
-                      <a:srgbClr val="26333D"/>
+                      <a:srgbClr val="0B3B2A"/>
                     </a:solidFill>
                   </a:tcPr>
                 </a:tc>
@@ -5272,7 +5207,7 @@
                       <a:r>
                         <a:rPr lang="en-US" sz="1400" b="1" dirty="0">
                           <a:solidFill>
-                            <a:srgbClr val="1B1F23"/>
+                            <a:srgbClr val="17211C"/>
                           </a:solidFill>
                         </a:rPr>
                         <a:t>Por que pagar R$ 6,8 se a Petrobras cobra R$ 3,30?</a:t>
@@ -5333,7 +5268,7 @@
                       <a:r>
                         <a:rPr lang="en-US" sz="1400" dirty="0">
                           <a:solidFill>
-                            <a:srgbClr val="1B1F23"/>
+                            <a:srgbClr val="17211C"/>
                           </a:solidFill>
                         </a:rPr>
                         <a:t>Não propomos travar 6,8 no volume todo. O call só paga se a paridade subir e cobre a fatia em que a Petrobras migra para ela.</a:t>
@@ -5396,7 +5331,7 @@
                       <a:r>
                         <a:rPr lang="en-US" sz="1400" b="1" dirty="0">
                           <a:solidFill>
-                            <a:srgbClr val="1B1F23"/>
+                            <a:srgbClr val="17211C"/>
                           </a:solidFill>
                         </a:rPr>
                         <a:t>E se a subvenção for renovada?</a:t>
@@ -5457,7 +5392,7 @@
                       <a:r>
                         <a:rPr lang="en-US" sz="1400" dirty="0">
                           <a:solidFill>
-                            <a:srgbClr val="1B1F23"/>
+                            <a:srgbClr val="17211C"/>
                           </a:solidFill>
                         </a:rPr>
                         <a:t>Perde-se o prêmio. O call segue protegendo contra alta de HO e câmbio, independente da Fazenda.</a:t>
@@ -5520,7 +5455,7 @@
                       <a:r>
                         <a:rPr lang="en-US" sz="1400" b="1" dirty="0">
                           <a:solidFill>
-                            <a:srgbClr val="1B1F23"/>
+                            <a:srgbClr val="17211C"/>
                           </a:solidFill>
                         </a:rPr>
                         <a:t>Qual o risco de base?</a:t>
@@ -5581,7 +5516,7 @@
                       <a:r>
                         <a:rPr lang="en-US" sz="1400" dirty="0">
                           <a:solidFill>
-                            <a:srgbClr val="1B1F23"/>
+                            <a:srgbClr val="17211C"/>
                           </a:solidFill>
                         </a:rPr>
                         <a:t>A Petrobras pode ficar abaixo da paridade por meses. Por isso hedge parcial e strike acima do termo.</a:t>
@@ -5644,7 +5579,7 @@
                       <a:r>
                         <a:rPr lang="en-US" sz="1400" b="1" dirty="0">
                           <a:solidFill>
-                            <a:srgbClr val="1B1F23"/>
+                            <a:srgbClr val="17211C"/>
                           </a:solidFill>
                         </a:rPr>
                         <a:t>A curva já não precifica tudo?</a:t>
@@ -5705,7 +5640,7 @@
                       <a:r>
                         <a:rPr lang="en-US" sz="1400" dirty="0">
                           <a:solidFill>
-                            <a:srgbClr val="1B1F23"/>
+                            <a:srgbClr val="17211C"/>
                           </a:solidFill>
                         </a:rPr>
                         <a:t>Brent dez/26 ~US$ 100 contra US$ 85 do Goldman. É seguro de cauda, não aposta de preço.</a:t>
@@ -5768,7 +5703,7 @@
                       <a:r>
                         <a:rPr lang="en-US" sz="1400" b="1" dirty="0">
                           <a:solidFill>
-                            <a:srgbClr val="1B1F23"/>
+                            <a:srgbClr val="17211C"/>
                           </a:solidFill>
                         </a:rPr>
                         <a:t>Serve para hedge accounting?</a:t>
@@ -5829,7 +5764,7 @@
                       <a:r>
                         <a:rPr lang="en-US" sz="1400" dirty="0">
                           <a:solidFill>
-                            <a:srgbClr val="1B1F23"/>
+                            <a:srgbClr val="17211C"/>
                           </a:solidFill>
                         </a:rPr>
                         <a:t>Depende da política da Suzano. Correlação paridade × preço pago precisa ser documentada.</a:t>
@@ -5986,7 +5921,7 @@
             <a:r>
               <a:rPr lang="en-US" sz="3200" b="1" dirty="0">
                 <a:solidFill>
-                  <a:srgbClr val="1B1F23"/>
+                  <a:srgbClr val="17211C"/>
                 </a:solidFill>
                 <a:latin typeface="Cambria" pitchFamily="34" charset="0"/>
                 <a:ea typeface="Cambria" pitchFamily="34" charset="-122"/>
@@ -6028,7 +5963,7 @@
             <a:r>
               <a:rPr lang="en-US" sz="1800" b="1" dirty="0">
                 <a:solidFill>
-                  <a:srgbClr val="C75A0B"/>
+                  <a:srgbClr val="00873A"/>
                 </a:solidFill>
                 <a:latin typeface="Calibri" pitchFamily="34" charset="0"/>
                 <a:ea typeface="Calibri" pitchFamily="34" charset="-122"/>
@@ -6049,7 +5984,7 @@
             <a:r>
               <a:rPr lang="en-US" sz="1600" dirty="0">
                 <a:solidFill>
-                  <a:srgbClr val="1B1F23"/>
+                  <a:srgbClr val="17211C"/>
                 </a:solidFill>
                 <a:latin typeface="Calibri" pitchFamily="34" charset="0"/>
                 <a:ea typeface="Calibri" pitchFamily="34" charset="-122"/>
@@ -6070,13 +6005,13 @@
             <a:r>
               <a:rPr lang="en-US" sz="1600" dirty="0">
                 <a:solidFill>
-                  <a:srgbClr val="1B1F23"/>
+                  <a:srgbClr val="17211C"/>
                 </a:solidFill>
                 <a:latin typeface="Calibri" pitchFamily="34" charset="0"/>
                 <a:ea typeface="Calibri" pitchFamily="34" charset="-122"/>
                 <a:cs typeface="Calibri" pitchFamily="34" charset="-120"/>
               </a:rPr>
-              <a:t>Bomba = 85% da variação na refinaria (B15, tributos fixos).</a:t>
+              <a:t>2º turno em 25/out; subvenção vence em 26/out.</a:t>
             </a:r>
             <a:endParaRPr lang="en-US" sz="1800" dirty="0"/>
           </a:p>
@@ -6091,13 +6026,13 @@
             <a:r>
               <a:rPr lang="en-US" sz="1600" dirty="0">
                 <a:solidFill>
-                  <a:srgbClr val="1B1F23"/>
+                  <a:srgbClr val="17211C"/>
                 </a:solidFill>
                 <a:latin typeface="Calibri" pitchFamily="34" charset="0"/>
                 <a:ea typeface="Calibri" pitchFamily="34" charset="-122"/>
                 <a:cs typeface="Calibri" pitchFamily="34" charset="-120"/>
               </a:rPr>
-              <a:t>2º turno em 25/out; subvenção vence em 26/out.</a:t>
+              <a:t>HO dez/26 entre US$ 4,4 e 4,6/gal (fontes divergem).</a:t>
             </a:r>
             <a:endParaRPr lang="en-US" sz="1800" dirty="0"/>
           </a:p>
@@ -6112,13 +6047,13 @@
             <a:r>
               <a:rPr lang="en-US" sz="1600" dirty="0">
                 <a:solidFill>
-                  <a:srgbClr val="1B1F23"/>
+                  <a:srgbClr val="17211C"/>
                 </a:solidFill>
                 <a:latin typeface="Calibri" pitchFamily="34" charset="0"/>
                 <a:ea typeface="Calibri" pitchFamily="34" charset="-122"/>
                 <a:cs typeface="Calibri" pitchFamily="34" charset="-120"/>
               </a:rPr>
-              <a:t>HO dez/26 entre US$ 4,4 e 4,6/gal (fontes divergem).</a:t>
+              <a:t>Câmbio de dezembro R$ 5,10 (termo estimado).</a:t>
             </a:r>
             <a:endParaRPr lang="en-US" sz="1800" dirty="0"/>
           </a:p>
@@ -6133,28 +6068,7 @@
             <a:r>
               <a:rPr lang="en-US" sz="1600" dirty="0">
                 <a:solidFill>
-                  <a:srgbClr val="1B1F23"/>
-                </a:solidFill>
-                <a:latin typeface="Calibri" pitchFamily="34" charset="0"/>
-                <a:ea typeface="Calibri" pitchFamily="34" charset="-122"/>
-                <a:cs typeface="Calibri" pitchFamily="34" charset="-120"/>
-              </a:rPr>
-              <a:t>Câmbio de dezembro R$ 5,10 (termo estimado).</a:t>
-            </a:r>
-            <a:endParaRPr lang="en-US" sz="1800" dirty="0"/>
-          </a:p>
-          <a:p>
-            <a:pPr marL="342900" indent="-342900">
-              <a:spcAft>
-                <a:spcPts val="800"/>
-              </a:spcAft>
-              <a:buSzPct val="100000"/>
-              <a:buChar char="•"/>
-            </a:pPr>
-            <a:r>
-              <a:rPr lang="en-US" sz="1600" dirty="0">
-                <a:solidFill>
-                  <a:srgbClr val="1B1F23"/>
+                  <a:srgbClr val="17211C"/>
                 </a:solidFill>
                 <a:latin typeface="Calibri" pitchFamily="34" charset="0"/>
                 <a:ea typeface="Calibri" pitchFamily="34" charset="-122"/>
@@ -6196,7 +6110,7 @@
             <a:r>
               <a:rPr lang="en-US" sz="1800" b="1" dirty="0">
                 <a:solidFill>
-                  <a:srgbClr val="C75A0B"/>
+                  <a:srgbClr val="00873A"/>
                 </a:solidFill>
                 <a:latin typeface="Calibri" pitchFamily="34" charset="0"/>
                 <a:ea typeface="Calibri" pitchFamily="34" charset="-122"/>
@@ -6216,7 +6130,7 @@
             <a:r>
               <a:rPr lang="en-US" sz="1400" u="sng" dirty="0">
                 <a:solidFill>
-                  <a:srgbClr val="1F6F6B"/>
+                  <a:srgbClr val="0B5D3B"/>
                 </a:solidFill>
                 <a:latin typeface="Calibri" pitchFamily="34" charset="0"/>
                 <a:ea typeface="Calibri" pitchFamily="34" charset="-122"/>
@@ -6243,7 +6157,7 @@
             <a:r>
               <a:rPr lang="en-US" sz="1400" u="sng" dirty="0">
                 <a:solidFill>
-                  <a:srgbClr val="1F6F6B"/>
+                  <a:srgbClr val="0B5D3B"/>
                 </a:solidFill>
                 <a:latin typeface="Calibri" pitchFamily="34" charset="0"/>
                 <a:ea typeface="Calibri" pitchFamily="34" charset="-122"/>
@@ -6270,7 +6184,7 @@
             <a:r>
               <a:rPr lang="en-US" sz="1400" u="sng" dirty="0">
                 <a:solidFill>
-                  <a:srgbClr val="1F6F6B"/>
+                  <a:srgbClr val="0B5D3B"/>
                 </a:solidFill>
                 <a:latin typeface="Calibri" pitchFamily="34" charset="0"/>
                 <a:ea typeface="Calibri" pitchFamily="34" charset="-122"/>
@@ -6297,7 +6211,7 @@
             <a:r>
               <a:rPr lang="en-US" sz="1400" u="sng" dirty="0">
                 <a:solidFill>
-                  <a:srgbClr val="1F6F6B"/>
+                  <a:srgbClr val="0B5D3B"/>
                 </a:solidFill>
                 <a:latin typeface="Calibri" pitchFamily="34" charset="0"/>
                 <a:ea typeface="Calibri" pitchFamily="34" charset="-122"/>
@@ -6324,7 +6238,7 @@
             <a:r>
               <a:rPr lang="en-US" sz="1400" u="sng" dirty="0">
                 <a:solidFill>
-                  <a:srgbClr val="1F6F6B"/>
+                  <a:srgbClr val="0B5D3B"/>
                 </a:solidFill>
                 <a:latin typeface="Calibri" pitchFamily="34" charset="0"/>
                 <a:ea typeface="Calibri" pitchFamily="34" charset="-122"/>
@@ -6351,7 +6265,7 @@
             <a:r>
               <a:rPr lang="en-US" sz="1400" u="sng" dirty="0">
                 <a:solidFill>
-                  <a:srgbClr val="1F6F6B"/>
+                  <a:srgbClr val="0B5D3B"/>
                 </a:solidFill>
                 <a:latin typeface="Calibri" pitchFamily="34" charset="0"/>
                 <a:ea typeface="Calibri" pitchFamily="34" charset="-122"/>
@@ -6364,7 +6278,7 @@
                   </a:extLst>
                 </a:hlinkClick>
               </a:rPr>
-              <a:t>Diesel R$ 7,35 (O Tempo)</a:t>
+              <a:t>Suzano 2T26 (SEC 6-K)</a:t>
             </a:r>
             <a:endParaRPr lang="en-US" sz="1800" dirty="0"/>
           </a:p>
@@ -6378,7 +6292,7 @@
             <a:r>
               <a:rPr lang="en-US" sz="1400" u="sng" dirty="0">
                 <a:solidFill>
-                  <a:srgbClr val="1F6F6B"/>
+                  <a:srgbClr val="0B5D3B"/>
                 </a:solidFill>
                 <a:latin typeface="Calibri" pitchFamily="34" charset="0"/>
                 <a:ea typeface="Calibri" pitchFamily="34" charset="-122"/>
@@ -6391,7 +6305,7 @@
                   </a:extLst>
                 </a:hlinkClick>
               </a:rPr>
-              <a:t>Suzano 2T26 (SEC 6-K)</a:t>
+              <a:t>Curva Brent e Goldman (Discovery Alert)</a:t>
             </a:r>
             <a:endParaRPr lang="en-US" sz="1800" dirty="0"/>
           </a:p>
@@ -6405,39 +6319,12 @@
             <a:r>
               <a:rPr lang="en-US" sz="1400" u="sng" dirty="0">
                 <a:solidFill>
-                  <a:srgbClr val="1F6F6B"/>
+                  <a:srgbClr val="0B5D3B"/>
                 </a:solidFill>
                 <a:latin typeface="Calibri" pitchFamily="34" charset="0"/>
                 <a:ea typeface="Calibri" pitchFamily="34" charset="-122"/>
                 <a:cs typeface="Calibri" pitchFamily="34" charset="-120"/>
                 <a:hlinkClick r:id="rId8" invalidUrl="" action="" tgtFrame="" tooltip="" history="1" highlightClick="0" endSnd="0">
-                  <a:extLst>
-                    <a:ext uri="{A12FA001-AC4F-418D-AE19-62706E023703}">
-                      <ahyp:hlinkClr xmlns:ahyp="http://schemas.microsoft.com/office/drawing/2018/hyperlinkcolor" val="tx"/>
-                    </a:ext>
-                  </a:extLst>
-                </a:hlinkClick>
-              </a:rPr>
-              <a:t>Curva Brent e Goldman (Discovery Alert)</a:t>
-            </a:r>
-            <a:endParaRPr lang="en-US" sz="1800" dirty="0"/>
-          </a:p>
-          <a:p>
-            <a:pPr indent="0" marL="0">
-              <a:spcAft>
-                <a:spcPts val="800"/>
-              </a:spcAft>
-              <a:buNone/>
-            </a:pPr>
-            <a:r>
-              <a:rPr lang="en-US" sz="1400" u="sng" dirty="0">
-                <a:solidFill>
-                  <a:srgbClr val="1F6F6B"/>
-                </a:solidFill>
-                <a:latin typeface="Calibri" pitchFamily="34" charset="0"/>
-                <a:ea typeface="Calibri" pitchFamily="34" charset="-122"/>
-                <a:cs typeface="Calibri" pitchFamily="34" charset="-120"/>
-                <a:hlinkClick r:id="rId9" invalidUrl="" action="" tgtFrame="" tooltip="" history="1" highlightClick="0" endSnd="0">
                   <a:extLst>
                     <a:ext uri="{A12FA001-AC4F-418D-AE19-62706E023703}">
                       <ahyp:hlinkClr xmlns:ahyp="http://schemas.microsoft.com/office/drawing/2018/hyperlinkcolor" val="tx"/>
@@ -6553,7 +6440,7 @@
             <a:r>
               <a:rPr lang="en-US" sz="3200" b="1" dirty="0">
                 <a:solidFill>
-                  <a:srgbClr val="1B1F23"/>
+                  <a:srgbClr val="17211C"/>
                 </a:solidFill>
                 <a:latin typeface="Cambria" pitchFamily="34" charset="0"/>
                 <a:ea typeface="Cambria" pitchFamily="34" charset="-122"/>
@@ -6582,11 +6469,11 @@
             </a:avLst>
           </a:prstGeom>
           <a:solidFill>
-            <a:srgbClr val="EEF0F1"/>
+            <a:srgbClr val="EDF2EE"/>
           </a:solidFill>
           <a:ln w="12700">
             <a:solidFill>
-              <a:srgbClr val="EEF0F1"/>
+              <a:srgbClr val="EDF2EE"/>
             </a:solidFill>
             <a:prstDash val="solid"/>
           </a:ln>
@@ -6617,9 +6504,9 @@
               <a:buNone/>
             </a:pPr>
             <a:r>
-              <a:rPr lang="en-US" sz="3800" b="1" dirty="0">
-                <a:solidFill>
-                  <a:srgbClr val="C75A0B"/>
+              <a:rPr lang="en-US" sz="3400" b="1" dirty="0">
+                <a:solidFill>
+                  <a:srgbClr val="00873A"/>
                 </a:solidFill>
                 <a:latin typeface="Cambria" pitchFamily="34" charset="0"/>
                 <a:ea typeface="Cambria" pitchFamily="34" charset="-122"/>
@@ -6627,7 +6514,7 @@
               </a:rPr>
               <a:t>R$ 2,12/L</a:t>
             </a:r>
-            <a:endParaRPr lang="en-US" sz="3800" dirty="0"/>
+            <a:endParaRPr lang="en-US" sz="3400" dirty="0"/>
           </a:p>
         </p:txBody>
       </p:sp>
@@ -6658,7 +6545,7 @@
             <a:r>
               <a:rPr lang="en-US" sz="1600" dirty="0">
                 <a:solidFill>
-                  <a:srgbClr val="1B1F23"/>
+                  <a:srgbClr val="17211C"/>
                 </a:solidFill>
                 <a:latin typeface="Calibri" pitchFamily="34" charset="0"/>
                 <a:ea typeface="Calibri" pitchFamily="34" charset="-122"/>
@@ -6687,11 +6574,11 @@
             </a:avLst>
           </a:prstGeom>
           <a:solidFill>
-            <a:srgbClr val="EEF0F1"/>
+            <a:srgbClr val="EDF2EE"/>
           </a:solidFill>
           <a:ln w="12700">
             <a:solidFill>
-              <a:srgbClr val="EEF0F1"/>
+              <a:srgbClr val="EDF2EE"/>
             </a:solidFill>
             <a:prstDash val="solid"/>
           </a:ln>
@@ -6722,9 +6609,9 @@
               <a:buNone/>
             </a:pPr>
             <a:r>
-              <a:rPr lang="en-US" sz="3800" b="1" dirty="0">
-                <a:solidFill>
-                  <a:srgbClr val="C75A0B"/>
+              <a:rPr lang="en-US" sz="3400" b="1" dirty="0">
+                <a:solidFill>
+                  <a:srgbClr val="00873A"/>
                 </a:solidFill>
                 <a:latin typeface="Cambria" pitchFamily="34" charset="0"/>
                 <a:ea typeface="Cambria" pitchFamily="34" charset="-122"/>
@@ -6732,7 +6619,7 @@
               </a:rPr>
               <a:t>R$ 3,27/L</a:t>
             </a:r>
-            <a:endParaRPr lang="en-US" sz="3800" dirty="0"/>
+            <a:endParaRPr lang="en-US" sz="3400" dirty="0"/>
           </a:p>
         </p:txBody>
       </p:sp>
@@ -6763,7 +6650,7 @@
             <a:r>
               <a:rPr lang="en-US" sz="1600" dirty="0">
                 <a:solidFill>
-                  <a:srgbClr val="1B1F23"/>
+                  <a:srgbClr val="17211C"/>
                 </a:solidFill>
                 <a:latin typeface="Calibri" pitchFamily="34" charset="0"/>
                 <a:ea typeface="Calibri" pitchFamily="34" charset="-122"/>
@@ -6792,11 +6679,11 @@
             </a:avLst>
           </a:prstGeom>
           <a:solidFill>
-            <a:srgbClr val="EEF0F1"/>
+            <a:srgbClr val="EDF2EE"/>
           </a:solidFill>
           <a:ln w="12700">
             <a:solidFill>
-              <a:srgbClr val="EEF0F1"/>
+              <a:srgbClr val="EDF2EE"/>
             </a:solidFill>
             <a:prstDash val="solid"/>
           </a:ln>
@@ -6827,17 +6714,17 @@
               <a:buNone/>
             </a:pPr>
             <a:r>
-              <a:rPr lang="en-US" sz="3800" b="1" dirty="0">
-                <a:solidFill>
-                  <a:srgbClr val="C75A0B"/>
+              <a:rPr lang="en-US" sz="3400" b="1" dirty="0">
+                <a:solidFill>
+                  <a:srgbClr val="00873A"/>
                 </a:solidFill>
                 <a:latin typeface="Cambria" pitchFamily="34" charset="0"/>
                 <a:ea typeface="Cambria" pitchFamily="34" charset="-122"/>
                 <a:cs typeface="Cambria" pitchFamily="34" charset="-120"/>
               </a:rPr>
-              <a:t>R$ 9 a 10/L</a:t>
+              <a:t>R$ 5,42 a 6,65/L</a:t>
             </a:r>
-            <a:endParaRPr lang="en-US" sz="3800" dirty="0"/>
+            <a:endParaRPr lang="en-US" sz="3400" dirty="0"/>
           </a:p>
         </p:txBody>
       </p:sp>
@@ -6868,13 +6755,13 @@
             <a:r>
               <a:rPr lang="en-US" sz="1600" dirty="0">
                 <a:solidFill>
-                  <a:srgbClr val="1B1F23"/>
+                  <a:srgbClr val="17211C"/>
                 </a:solidFill>
                 <a:latin typeface="Calibri" pitchFamily="34" charset="0"/>
                 <a:ea typeface="Calibri" pitchFamily="34" charset="-122"/>
                 <a:cs typeface="Calibri" pitchFamily="34" charset="-120"/>
               </a:rPr>
-              <a:t>preço na bomba (S-10) se a subvenção acabar ou se a Petrobras for à paridade; hoje R$ 7,35/L</a:t>
+              <a:t>preço ao distribuidor se a subvenção acabar (cenário 4) ou se a Petrobras for à paridade; hoje R$ 3,30/L</a:t>
             </a:r>
             <a:endParaRPr lang="en-US" sz="1600" dirty="0"/>
           </a:p>
@@ -6897,11 +6784,11 @@
             </a:avLst>
           </a:prstGeom>
           <a:solidFill>
-            <a:srgbClr val="26333D"/>
+            <a:srgbClr val="0B3B2A"/>
           </a:solidFill>
           <a:ln w="12700">
             <a:solidFill>
-              <a:srgbClr val="26333D"/>
+              <a:srgbClr val="0B3B2A"/>
             </a:solidFill>
             <a:prstDash val="solid"/>
           </a:ln>
@@ -6937,7 +6824,7 @@
             <a:r>
               <a:rPr lang="en-US" sz="1800" b="1" dirty="0">
                 <a:solidFill>
-                  <a:srgbClr val="E9B44C"/>
+                  <a:srgbClr val="FFCB05"/>
                 </a:solidFill>
                 <a:latin typeface="Calibri" pitchFamily="34" charset="0"/>
                 <a:ea typeface="Calibri" pitchFamily="34" charset="-122"/>
@@ -7068,7 +6955,7 @@
             <a:r>
               <a:rPr lang="en-US" sz="3200" b="1" dirty="0">
                 <a:solidFill>
-                  <a:srgbClr val="1B1F23"/>
+                  <a:srgbClr val="17211C"/>
                 </a:solidFill>
                 <a:latin typeface="Cambria" pitchFamily="34" charset="0"/>
                 <a:ea typeface="Cambria" pitchFamily="34" charset="-122"/>
@@ -7123,7 +7010,7 @@
             <a:r>
               <a:rPr lang="en-US" sz="1600" b="1" dirty="0">
                 <a:solidFill>
-                  <a:srgbClr val="1B1F23"/>
+                  <a:srgbClr val="17211C"/>
                 </a:solidFill>
                 <a:latin typeface="Calibri" pitchFamily="34" charset="0"/>
                 <a:ea typeface="Calibri" pitchFamily="34" charset="-122"/>
@@ -7166,7 +7053,7 @@
             <a:r>
               <a:rPr lang="en-US" sz="1600" dirty="0">
                 <a:solidFill>
-                  <a:srgbClr val="1B1F23"/>
+                  <a:srgbClr val="17211C"/>
                 </a:solidFill>
                 <a:latin typeface="Calibri" pitchFamily="34" charset="0"/>
                 <a:ea typeface="Calibri" pitchFamily="34" charset="-122"/>
@@ -7187,7 +7074,7 @@
             <a:r>
               <a:rPr lang="en-US" sz="1600" dirty="0">
                 <a:solidFill>
-                  <a:srgbClr val="1B1F23"/>
+                  <a:srgbClr val="17211C"/>
                 </a:solidFill>
                 <a:latin typeface="Calibri" pitchFamily="34" charset="0"/>
                 <a:ea typeface="Calibri" pitchFamily="34" charset="-122"/>
@@ -7208,7 +7095,7 @@
             <a:r>
               <a:rPr lang="en-US" sz="1600" dirty="0">
                 <a:solidFill>
-                  <a:srgbClr val="1B1F23"/>
+                  <a:srgbClr val="17211C"/>
                 </a:solidFill>
                 <a:latin typeface="Calibri" pitchFamily="34" charset="0"/>
                 <a:ea typeface="Calibri" pitchFamily="34" charset="-122"/>
@@ -7229,7 +7116,7 @@
             <a:r>
               <a:rPr lang="en-US" sz="1600" dirty="0">
                 <a:solidFill>
-                  <a:srgbClr val="1B1F23"/>
+                  <a:srgbClr val="17211C"/>
                 </a:solidFill>
                 <a:latin typeface="Calibri" pitchFamily="34" charset="0"/>
                 <a:ea typeface="Calibri" pitchFamily="34" charset="-122"/>
@@ -7343,13 +7230,13 @@
             <a:r>
               <a:rPr lang="en-US" sz="3200" b="1" dirty="0">
                 <a:solidFill>
-                  <a:srgbClr val="1B1F23"/>
+                  <a:srgbClr val="17211C"/>
                 </a:solidFill>
                 <a:latin typeface="Cambria" pitchFamily="34" charset="0"/>
                 <a:ea typeface="Cambria" pitchFamily="34" charset="-122"/>
                 <a:cs typeface="Cambria" pitchFamily="34" charset="-120"/>
               </a:rPr>
-              <a:t>Cinco cenários: do status quo (R$ 7,4) ao teto de paridade (R$ 10,2 na bomba)</a:t>
+              <a:t>Cinco cenários: do status quo (R$ 3,30/L) ao teto de paridade (≈ R$ 6,65/L)</a:t>
             </a:r>
             <a:endParaRPr lang="en-US" sz="3200" dirty="0"/>
           </a:p>
@@ -7378,12 +7265,11 @@
             <a:tbl>
               <a:tblPr/>
               <a:tblGrid>
-                <a:gridCol w="1828800"/>
-                <a:gridCol w="3291840"/>
+                <a:gridCol w="2011680"/>
+                <a:gridCol w="4206240"/>
+                <a:gridCol w="1737360"/>
+                <a:gridCol w="1463040"/>
                 <a:gridCol w="1645920"/>
-                <a:gridCol w="1280160"/>
-                <a:gridCol w="1463040"/>
-                <a:gridCol w="1554480"/>
               </a:tblGrid>
               <a:tr h="640080">
                 <a:tc>
@@ -7443,7 +7329,7 @@
                       <a:tailEnd type="none" w="med" len="med"/>
                     </a:lnB>
                     <a:solidFill>
-                      <a:srgbClr val="26333D"/>
+                      <a:srgbClr val="0B3B2A"/>
                     </a:solidFill>
                   </a:tcPr>
                 </a:tc>
@@ -7504,7 +7390,7 @@
                       <a:tailEnd type="none" w="med" len="med"/>
                     </a:lnB>
                     <a:solidFill>
-                      <a:srgbClr val="26333D"/>
+                      <a:srgbClr val="0B3B2A"/>
                     </a:solidFill>
                   </a:tcPr>
                 </a:tc>
@@ -7565,7 +7451,7 @@
                       <a:tailEnd type="none" w="med" len="med"/>
                     </a:lnB>
                     <a:solidFill>
-                      <a:srgbClr val="26333D"/>
+                      <a:srgbClr val="0B3B2A"/>
                     </a:solidFill>
                   </a:tcPr>
                 </a:tc>
@@ -7626,68 +7512,7 @@
                       <a:tailEnd type="none" w="med" len="med"/>
                     </a:lnB>
                     <a:solidFill>
-                      <a:srgbClr val="26333D"/>
-                    </a:solidFill>
-                  </a:tcPr>
-                </a:tc>
-                <a:tc>
-                  <a:txBody>
-                    <a:bodyPr/>
-                    <a:lstStyle/>
-                    <a:p>
-                      <a:pPr indent="0" marL="0">
-                        <a:buNone/>
-                      </a:pPr>
-                      <a:r>
-                        <a:rPr lang="en-US" sz="1400" b="1" dirty="0">
-                          <a:solidFill>
-                            <a:srgbClr val="FFFFFF"/>
-                          </a:solidFill>
-                        </a:rPr>
-                        <a:t>Bomba S-10 (R$/L)</a:t>
-                      </a:r>
-                      <a:endParaRPr lang="en-US" sz="1400" dirty="0"/>
-                    </a:p>
-                  </a:txBody>
-                  <a:tcPr marL="91440" marR="91440" marT="45720" marB="45720" anchor="ctr">
-                    <a:lnL w="9525" cap="flat" cmpd="sng" algn="ctr">
-                      <a:solidFill>
-                        <a:srgbClr val="D5DADD"/>
-                      </a:solidFill>
-                      <a:prstDash val="solid"/>
-                      <a:round/>
-                      <a:headEnd type="none" w="med" len="med"/>
-                      <a:tailEnd type="none" w="med" len="med"/>
-                    </a:lnL>
-                    <a:lnR w="9525" cap="flat" cmpd="sng" algn="ctr">
-                      <a:solidFill>
-                        <a:srgbClr val="D5DADD"/>
-                      </a:solidFill>
-                      <a:prstDash val="solid"/>
-                      <a:round/>
-                      <a:headEnd type="none" w="med" len="med"/>
-                      <a:tailEnd type="none" w="med" len="med"/>
-                    </a:lnR>
-                    <a:lnT w="9525" cap="flat" cmpd="sng" algn="ctr">
-                      <a:solidFill>
-                        <a:srgbClr val="D5DADD"/>
-                      </a:solidFill>
-                      <a:prstDash val="solid"/>
-                      <a:round/>
-                      <a:headEnd type="none" w="med" len="med"/>
-                      <a:tailEnd type="none" w="med" len="med"/>
-                    </a:lnT>
-                    <a:lnB w="9525" cap="flat" cmpd="sng" algn="ctr">
-                      <a:solidFill>
-                        <a:srgbClr val="D5DADD"/>
-                      </a:solidFill>
-                      <a:prstDash val="solid"/>
-                      <a:round/>
-                      <a:headEnd type="none" w="med" len="med"/>
-                      <a:tailEnd type="none" w="med" len="med"/>
-                    </a:lnB>
-                    <a:solidFill>
-                      <a:srgbClr val="26333D"/>
+                      <a:srgbClr val="0B3B2A"/>
                     </a:solidFill>
                   </a:tcPr>
                 </a:tc>
@@ -7748,7 +7573,7 @@
                       <a:tailEnd type="none" w="med" len="med"/>
                     </a:lnB>
                     <a:solidFill>
-                      <a:srgbClr val="26333D"/>
+                      <a:srgbClr val="0B3B2A"/>
                     </a:solidFill>
                   </a:tcPr>
                 </a:tc>
@@ -7765,7 +7590,7 @@
                       <a:r>
                         <a:rPr lang="en-US" sz="1400" b="1" dirty="0">
                           <a:solidFill>
-                            <a:srgbClr val="1B1F23"/>
+                            <a:srgbClr val="17211C"/>
                           </a:solidFill>
                         </a:rPr>
                         <a:t>1. Desescalada</a:t>
@@ -7826,7 +7651,7 @@
                       <a:r>
                         <a:rPr lang="en-US" sz="1400" dirty="0">
                           <a:solidFill>
-                            <a:srgbClr val="1B1F23"/>
+                            <a:srgbClr val="17211C"/>
                           </a:solidFill>
                         </a:rPr>
                         <a:t>Brent e crack caem; subvenção encolhe na mesma proporção</a:t>
@@ -7887,7 +7712,7 @@
                       <a:r>
                         <a:rPr lang="en-US" sz="1400" dirty="0">
                           <a:solidFill>
-                            <a:srgbClr val="1B1F23"/>
+                            <a:srgbClr val="17211C"/>
                           </a:solidFill>
                         </a:rPr>
                         <a:t>3,30</a:t>
@@ -7948,7 +7773,7 @@
                       <a:r>
                         <a:rPr lang="en-US" sz="1400" dirty="0">
                           <a:solidFill>
-                            <a:srgbClr val="1B1F23"/>
+                            <a:srgbClr val="17211C"/>
                           </a:solidFill>
                         </a:rPr>
                         <a:t>0</a:t>
@@ -8009,68 +7834,7 @@
                       <a:r>
                         <a:rPr lang="en-US" sz="1400" dirty="0">
                           <a:solidFill>
-                            <a:srgbClr val="1B1F23"/>
-                          </a:solidFill>
-                        </a:rPr>
-                        <a:t>7,10 a 7,35</a:t>
-                      </a:r>
-                      <a:endParaRPr lang="en-US" sz="1400" dirty="0"/>
-                    </a:p>
-                  </a:txBody>
-                  <a:tcPr marL="91440" marR="91440" marT="45720" marB="45720" anchor="ctr">
-                    <a:lnL w="9525" cap="flat" cmpd="sng" algn="ctr">
-                      <a:solidFill>
-                        <a:srgbClr val="D5DADD"/>
-                      </a:solidFill>
-                      <a:prstDash val="solid"/>
-                      <a:round/>
-                      <a:headEnd type="none" w="med" len="med"/>
-                      <a:tailEnd type="none" w="med" len="med"/>
-                    </a:lnL>
-                    <a:lnR w="9525" cap="flat" cmpd="sng" algn="ctr">
-                      <a:solidFill>
-                        <a:srgbClr val="D5DADD"/>
-                      </a:solidFill>
-                      <a:prstDash val="solid"/>
-                      <a:round/>
-                      <a:headEnd type="none" w="med" len="med"/>
-                      <a:tailEnd type="none" w="med" len="med"/>
-                    </a:lnR>
-                    <a:lnT w="9525" cap="flat" cmpd="sng" algn="ctr">
-                      <a:solidFill>
-                        <a:srgbClr val="D5DADD"/>
-                      </a:solidFill>
-                      <a:prstDash val="solid"/>
-                      <a:round/>
-                      <a:headEnd type="none" w="med" len="med"/>
-                      <a:tailEnd type="none" w="med" len="med"/>
-                    </a:lnT>
-                    <a:lnB w="9525" cap="flat" cmpd="sng" algn="ctr">
-                      <a:solidFill>
-                        <a:srgbClr val="D5DADD"/>
-                      </a:solidFill>
-                      <a:prstDash val="solid"/>
-                      <a:round/>
-                      <a:headEnd type="none" w="med" len="med"/>
-                      <a:tailEnd type="none" w="med" len="med"/>
-                    </a:lnB>
-                    <a:solidFill>
-                      <a:srgbClr val="FFFFFF"/>
-                    </a:solidFill>
-                  </a:tcPr>
-                </a:tc>
-                <a:tc>
-                  <a:txBody>
-                    <a:bodyPr/>
-                    <a:lstStyle/>
-                    <a:p>
-                      <a:pPr indent="0" marL="0">
-                        <a:buNone/>
-                      </a:pPr>
-                      <a:r>
-                        <a:rPr lang="en-US" sz="1400" dirty="0">
-                          <a:solidFill>
-                            <a:srgbClr val="1B1F23"/>
+                            <a:srgbClr val="17211C"/>
                           </a:solidFill>
                         </a:rPr>
                         <a:t>Média a baixa</a:t>
@@ -8133,7 +7897,7 @@
                       <a:r>
                         <a:rPr lang="en-US" sz="1400" b="1" dirty="0">
                           <a:solidFill>
-                            <a:srgbClr val="1B1F23"/>
+                            <a:srgbClr val="17211C"/>
                           </a:solidFill>
                         </a:rPr>
                         <a:t>2. Status quo</a:t>
@@ -8194,7 +7958,7 @@
                       <a:r>
                         <a:rPr lang="en-US" sz="1400" dirty="0">
                           <a:solidFill>
-                            <a:srgbClr val="1B1F23"/>
+                            <a:srgbClr val="17211C"/>
                           </a:solidFill>
                         </a:rPr>
                         <a:t>Subvenção de R$ 2,12 renovada em 26/out</a:t>
@@ -8255,7 +8019,7 @@
                       <a:r>
                         <a:rPr lang="en-US" sz="1400" dirty="0">
                           <a:solidFill>
-                            <a:srgbClr val="1B1F23"/>
+                            <a:srgbClr val="17211C"/>
                           </a:solidFill>
                         </a:rPr>
                         <a:t>3,30</a:t>
@@ -8316,7 +8080,7 @@
                       <a:r>
                         <a:rPr lang="en-US" sz="1400" dirty="0">
                           <a:solidFill>
-                            <a:srgbClr val="1B1F23"/>
+                            <a:srgbClr val="17211C"/>
                           </a:solidFill>
                         </a:rPr>
                         <a:t>0</a:t>
@@ -8377,68 +8141,7 @@
                       <a:r>
                         <a:rPr lang="en-US" sz="1400" dirty="0">
                           <a:solidFill>
-                            <a:srgbClr val="1B1F23"/>
-                          </a:solidFill>
-                        </a:rPr>
-                        <a:t>7,25 a 7,60</a:t>
-                      </a:r>
-                      <a:endParaRPr lang="en-US" sz="1400" dirty="0"/>
-                    </a:p>
-                  </a:txBody>
-                  <a:tcPr marL="91440" marR="91440" marT="45720" marB="45720" anchor="ctr">
-                    <a:lnL w="9525" cap="flat" cmpd="sng" algn="ctr">
-                      <a:solidFill>
-                        <a:srgbClr val="D5DADD"/>
-                      </a:solidFill>
-                      <a:prstDash val="solid"/>
-                      <a:round/>
-                      <a:headEnd type="none" w="med" len="med"/>
-                      <a:tailEnd type="none" w="med" len="med"/>
-                    </a:lnL>
-                    <a:lnR w="9525" cap="flat" cmpd="sng" algn="ctr">
-                      <a:solidFill>
-                        <a:srgbClr val="D5DADD"/>
-                      </a:solidFill>
-                      <a:prstDash val="solid"/>
-                      <a:round/>
-                      <a:headEnd type="none" w="med" len="med"/>
-                      <a:tailEnd type="none" w="med" len="med"/>
-                    </a:lnR>
-                    <a:lnT w="9525" cap="flat" cmpd="sng" algn="ctr">
-                      <a:solidFill>
-                        <a:srgbClr val="D5DADD"/>
-                      </a:solidFill>
-                      <a:prstDash val="solid"/>
-                      <a:round/>
-                      <a:headEnd type="none" w="med" len="med"/>
-                      <a:tailEnd type="none" w="med" len="med"/>
-                    </a:lnT>
-                    <a:lnB w="9525" cap="flat" cmpd="sng" algn="ctr">
-                      <a:solidFill>
-                        <a:srgbClr val="D5DADD"/>
-                      </a:solidFill>
-                      <a:prstDash val="solid"/>
-                      <a:round/>
-                      <a:headEnd type="none" w="med" len="med"/>
-                      <a:tailEnd type="none" w="med" len="med"/>
-                    </a:lnB>
-                    <a:solidFill>
-                      <a:srgbClr val="FFFFFF"/>
-                    </a:solidFill>
-                  </a:tcPr>
-                </a:tc>
-                <a:tc>
-                  <a:txBody>
-                    <a:bodyPr/>
-                    <a:lstStyle/>
-                    <a:p>
-                      <a:pPr indent="0" marL="0">
-                        <a:buNone/>
-                      </a:pPr>
-                      <a:r>
-                        <a:rPr lang="en-US" sz="1400" dirty="0">
-                          <a:solidFill>
-                            <a:srgbClr val="1B1F23"/>
+                            <a:srgbClr val="17211C"/>
                           </a:solidFill>
                         </a:rPr>
                         <a:t>Alta</a:t>
@@ -8501,7 +8204,7 @@
                       <a:r>
                         <a:rPr lang="en-US" sz="1400" b="1" dirty="0">
                           <a:solidFill>
-                            <a:srgbClr val="1B1F23"/>
+                            <a:srgbClr val="17211C"/>
                           </a:solidFill>
                         </a:rPr>
                         <a:t>3. Retirada parcial</a:t>
@@ -8562,7 +8265,7 @@
                       <a:r>
                         <a:rPr lang="en-US" sz="1400" dirty="0">
                           <a:solidFill>
-                            <a:srgbClr val="1B1F23"/>
+                            <a:srgbClr val="17211C"/>
                           </a:solidFill>
                         </a:rPr>
                         <a:t>Cai a camada de R$ 1,00 criada em setembro</a:t>
@@ -8623,7 +8326,7 @@
                       <a:r>
                         <a:rPr lang="en-US" sz="1400" dirty="0">
                           <a:solidFill>
-                            <a:srgbClr val="1B1F23"/>
+                            <a:srgbClr val="17211C"/>
                           </a:solidFill>
                         </a:rPr>
                         <a:t>4,30</a:t>
@@ -8684,7 +8387,7 @@
                       <a:r>
                         <a:rPr lang="en-US" sz="1400" dirty="0">
                           <a:solidFill>
-                            <a:srgbClr val="1B1F23"/>
+                            <a:srgbClr val="17211C"/>
                           </a:solidFill>
                         </a:rPr>
                         <a:t>+1,00</a:t>
@@ -8745,68 +8448,7 @@
                       <a:r>
                         <a:rPr lang="en-US" sz="1400" dirty="0">
                           <a:solidFill>
-                            <a:srgbClr val="1B1F23"/>
-                          </a:solidFill>
-                        </a:rPr>
-                        <a:t>≈ 8,20</a:t>
-                      </a:r>
-                      <a:endParaRPr lang="en-US" sz="1400" dirty="0"/>
-                    </a:p>
-                  </a:txBody>
-                  <a:tcPr marL="91440" marR="91440" marT="45720" marB="45720" anchor="ctr">
-                    <a:lnL w="9525" cap="flat" cmpd="sng" algn="ctr">
-                      <a:solidFill>
-                        <a:srgbClr val="D5DADD"/>
-                      </a:solidFill>
-                      <a:prstDash val="solid"/>
-                      <a:round/>
-                      <a:headEnd type="none" w="med" len="med"/>
-                      <a:tailEnd type="none" w="med" len="med"/>
-                    </a:lnL>
-                    <a:lnR w="9525" cap="flat" cmpd="sng" algn="ctr">
-                      <a:solidFill>
-                        <a:srgbClr val="D5DADD"/>
-                      </a:solidFill>
-                      <a:prstDash val="solid"/>
-                      <a:round/>
-                      <a:headEnd type="none" w="med" len="med"/>
-                      <a:tailEnd type="none" w="med" len="med"/>
-                    </a:lnR>
-                    <a:lnT w="9525" cap="flat" cmpd="sng" algn="ctr">
-                      <a:solidFill>
-                        <a:srgbClr val="D5DADD"/>
-                      </a:solidFill>
-                      <a:prstDash val="solid"/>
-                      <a:round/>
-                      <a:headEnd type="none" w="med" len="med"/>
-                      <a:tailEnd type="none" w="med" len="med"/>
-                    </a:lnT>
-                    <a:lnB w="9525" cap="flat" cmpd="sng" algn="ctr">
-                      <a:solidFill>
-                        <a:srgbClr val="D5DADD"/>
-                      </a:solidFill>
-                      <a:prstDash val="solid"/>
-                      <a:round/>
-                      <a:headEnd type="none" w="med" len="med"/>
-                      <a:tailEnd type="none" w="med" len="med"/>
-                    </a:lnB>
-                    <a:solidFill>
-                      <a:srgbClr val="FFFFFF"/>
-                    </a:solidFill>
-                  </a:tcPr>
-                </a:tc>
-                <a:tc>
-                  <a:txBody>
-                    <a:bodyPr/>
-                    <a:lstStyle/>
-                    <a:p>
-                      <a:pPr indent="0" marL="0">
-                        <a:buNone/>
-                      </a:pPr>
-                      <a:r>
-                        <a:rPr lang="en-US" sz="1400" dirty="0">
-                          <a:solidFill>
-                            <a:srgbClr val="1B1F23"/>
+                            <a:srgbClr val="17211C"/>
                           </a:solidFill>
                         </a:rPr>
                         <a:t>Média</a:t>
@@ -8930,7 +8572,7 @@
                       <a:r>
                         <a:rPr lang="en-US" sz="1400" dirty="0">
                           <a:solidFill>
-                            <a:srgbClr val="1B1F23"/>
+                            <a:srgbClr val="17211C"/>
                           </a:solidFill>
                         </a:rPr>
                         <a:t>Subvenção zerada; Petrobras mantém o preço bruto</a:t>
@@ -8991,7 +8633,7 @@
                       <a:r>
                         <a:rPr lang="en-US" sz="1400" dirty="0">
                           <a:solidFill>
-                            <a:srgbClr val="1B1F23"/>
+                            <a:srgbClr val="17211C"/>
                           </a:solidFill>
                         </a:rPr>
                         <a:t>5,42</a:t>
@@ -9052,7 +8694,7 @@
                       <a:r>
                         <a:rPr lang="en-US" sz="1400" dirty="0">
                           <a:solidFill>
-                            <a:srgbClr val="1B1F23"/>
+                            <a:srgbClr val="17211C"/>
                           </a:solidFill>
                         </a:rPr>
                         <a:t>+2,12</a:t>
@@ -9113,68 +8755,7 @@
                       <a:r>
                         <a:rPr lang="en-US" sz="1400" dirty="0">
                           <a:solidFill>
-                            <a:srgbClr val="1B1F23"/>
-                          </a:solidFill>
-                        </a:rPr>
-                        <a:t>≈ 9,15</a:t>
-                      </a:r>
-                      <a:endParaRPr lang="en-US" sz="1400" dirty="0"/>
-                    </a:p>
-                  </a:txBody>
-                  <a:tcPr marL="91440" marR="91440" marT="45720" marB="45720" anchor="ctr">
-                    <a:lnL w="9525" cap="flat" cmpd="sng" algn="ctr">
-                      <a:solidFill>
-                        <a:srgbClr val="D5DADD"/>
-                      </a:solidFill>
-                      <a:prstDash val="solid"/>
-                      <a:round/>
-                      <a:headEnd type="none" w="med" len="med"/>
-                      <a:tailEnd type="none" w="med" len="med"/>
-                    </a:lnL>
-                    <a:lnR w="9525" cap="flat" cmpd="sng" algn="ctr">
-                      <a:solidFill>
-                        <a:srgbClr val="D5DADD"/>
-                      </a:solidFill>
-                      <a:prstDash val="solid"/>
-                      <a:round/>
-                      <a:headEnd type="none" w="med" len="med"/>
-                      <a:tailEnd type="none" w="med" len="med"/>
-                    </a:lnR>
-                    <a:lnT w="9525" cap="flat" cmpd="sng" algn="ctr">
-                      <a:solidFill>
-                        <a:srgbClr val="D5DADD"/>
-                      </a:solidFill>
-                      <a:prstDash val="solid"/>
-                      <a:round/>
-                      <a:headEnd type="none" w="med" len="med"/>
-                      <a:tailEnd type="none" w="med" len="med"/>
-                    </a:lnT>
-                    <a:lnB w="9525" cap="flat" cmpd="sng" algn="ctr">
-                      <a:solidFill>
-                        <a:srgbClr val="D5DADD"/>
-                      </a:solidFill>
-                      <a:prstDash val="solid"/>
-                      <a:round/>
-                      <a:headEnd type="none" w="med" len="med"/>
-                      <a:tailEnd type="none" w="med" len="med"/>
-                    </a:lnB>
-                    <a:solidFill>
-                      <a:srgbClr val="FFFFFF"/>
-                    </a:solidFill>
-                  </a:tcPr>
-                </a:tc>
-                <a:tc>
-                  <a:txBody>
-                    <a:bodyPr/>
-                    <a:lstStyle/>
-                    <a:p>
-                      <a:pPr indent="0" marL="0">
-                        <a:buNone/>
-                      </a:pPr>
-                      <a:r>
-                        <a:rPr lang="en-US" sz="1400" dirty="0">
-                          <a:solidFill>
-                            <a:srgbClr val="1B1F23"/>
+                            <a:srgbClr val="17211C"/>
                           </a:solidFill>
                         </a:rPr>
                         <a:t>Baixa a média</a:t>
@@ -9298,7 +8879,7 @@
                       <a:r>
                         <a:rPr lang="en-US" sz="1400" dirty="0">
                           <a:solidFill>
-                            <a:srgbClr val="1B1F23"/>
+                            <a:srgbClr val="17211C"/>
                           </a:solidFill>
                         </a:rPr>
                         <a:t>Subvenção zerada e preço levado à paridade</a:t>
@@ -9359,7 +8940,7 @@
                       <a:r>
                         <a:rPr lang="en-US" sz="1400" dirty="0">
                           <a:solidFill>
-                            <a:srgbClr val="1B1F23"/>
+                            <a:srgbClr val="17211C"/>
                           </a:solidFill>
                         </a:rPr>
                         <a:t>≈ 6,65</a:t>
@@ -9420,7 +9001,7 @@
                       <a:r>
                         <a:rPr lang="en-US" sz="1400" dirty="0">
                           <a:solidFill>
-                            <a:srgbClr val="1B1F23"/>
+                            <a:srgbClr val="17211C"/>
                           </a:solidFill>
                         </a:rPr>
                         <a:t>+3,3 a +3,4</a:t>
@@ -9481,68 +9062,7 @@
                       <a:r>
                         <a:rPr lang="en-US" sz="1400" dirty="0">
                           <a:solidFill>
-                            <a:srgbClr val="1B1F23"/>
-                          </a:solidFill>
-                        </a:rPr>
-                        <a:t>≈ 10,1 a 10,3</a:t>
-                      </a:r>
-                      <a:endParaRPr lang="en-US" sz="1400" dirty="0"/>
-                    </a:p>
-                  </a:txBody>
-                  <a:tcPr marL="91440" marR="91440" marT="45720" marB="45720" anchor="ctr">
-                    <a:lnL w="9525" cap="flat" cmpd="sng" algn="ctr">
-                      <a:solidFill>
-                        <a:srgbClr val="D5DADD"/>
-                      </a:solidFill>
-                      <a:prstDash val="solid"/>
-                      <a:round/>
-                      <a:headEnd type="none" w="med" len="med"/>
-                      <a:tailEnd type="none" w="med" len="med"/>
-                    </a:lnL>
-                    <a:lnR w="9525" cap="flat" cmpd="sng" algn="ctr">
-                      <a:solidFill>
-                        <a:srgbClr val="D5DADD"/>
-                      </a:solidFill>
-                      <a:prstDash val="solid"/>
-                      <a:round/>
-                      <a:headEnd type="none" w="med" len="med"/>
-                      <a:tailEnd type="none" w="med" len="med"/>
-                    </a:lnR>
-                    <a:lnT w="9525" cap="flat" cmpd="sng" algn="ctr">
-                      <a:solidFill>
-                        <a:srgbClr val="D5DADD"/>
-                      </a:solidFill>
-                      <a:prstDash val="solid"/>
-                      <a:round/>
-                      <a:headEnd type="none" w="med" len="med"/>
-                      <a:tailEnd type="none" w="med" len="med"/>
-                    </a:lnT>
-                    <a:lnB w="9525" cap="flat" cmpd="sng" algn="ctr">
-                      <a:solidFill>
-                        <a:srgbClr val="D5DADD"/>
-                      </a:solidFill>
-                      <a:prstDash val="solid"/>
-                      <a:round/>
-                      <a:headEnd type="none" w="med" len="med"/>
-                      <a:tailEnd type="none" w="med" len="med"/>
-                    </a:lnB>
-                    <a:solidFill>
-                      <a:srgbClr val="FFFFFF"/>
-                    </a:solidFill>
-                  </a:tcPr>
-                </a:tc>
-                <a:tc>
-                  <a:txBody>
-                    <a:bodyPr/>
-                    <a:lstStyle/>
-                    <a:p>
-                      <a:pPr indent="0" marL="0">
-                        <a:buNone/>
-                      </a:pPr>
-                      <a:r>
-                        <a:rPr lang="en-US" sz="1400" dirty="0">
-                          <a:solidFill>
-                            <a:srgbClr val="1B1F23"/>
+                            <a:srgbClr val="17211C"/>
                           </a:solidFill>
                         </a:rPr>
                         <a:t>Baixa</a:t>
@@ -9630,7 +9150,7 @@
                 <a:ea typeface="Calibri" pitchFamily="34" charset="-122"/>
                 <a:cs typeface="Calibri" pitchFamily="34" charset="-120"/>
               </a:rPr>
-              <a:t>Bomba = 85% da variação na refinaria (mistura de ~15% de biodiesel e tributos fixos por litro, a confirmar). Base: R$ 7,35/L (ANP). Plausibilidade é leitura qualitativa, não probabilidade.</a:t>
+              <a:t>Preço ao distribuidor de diesel A (média Petrobras, R$ por litro). Plausibilidade é leitura qualitativa, não probabilidade.</a:t>
             </a:r>
             <a:endParaRPr lang="en-US" sz="1200" dirty="0"/>
           </a:p>
@@ -9738,13 +9258,13 @@
             <a:r>
               <a:rPr lang="en-US" sz="3200" b="1" dirty="0">
                 <a:solidFill>
-                  <a:srgbClr val="1B1F23"/>
+                  <a:srgbClr val="17211C"/>
                 </a:solidFill>
                 <a:latin typeface="Cambria" pitchFamily="34" charset="0"/>
                 <a:ea typeface="Cambria" pitchFamily="34" charset="-122"/>
                 <a:cs typeface="Cambria" pitchFamily="34" charset="-120"/>
               </a:rPr>
-              <a:t>Entre o status quo e o teto, a bomba sobe cerca de R$ 2,8/L</a:t>
+              <a:t>Entre o status quo e o teto, o preço ao distribuidor sobe até R$ 3,35/L</a:t>
             </a:r>
             <a:endParaRPr lang="en-US" sz="3200" dirty="0"/>
           </a:p>
@@ -9868,7 +9388,7 @@
             <a:r>
               <a:rPr lang="en-US" sz="3200" b="1" dirty="0">
                 <a:solidFill>
-                  <a:srgbClr val="1B1F23"/>
+                  <a:srgbClr val="17211C"/>
                 </a:solidFill>
                 <a:latin typeface="Cambria" pitchFamily="34" charset="0"/>
                 <a:ea typeface="Cambria" pitchFamily="34" charset="-122"/>
@@ -9994,7 +9514,7 @@
             <a:r>
               <a:rPr lang="en-US" sz="1400" dirty="0">
                 <a:solidFill>
-                  <a:srgbClr val="1B1F23"/>
+                  <a:srgbClr val="17211C"/>
                 </a:solidFill>
                 <a:latin typeface="Calibri" pitchFamily="34" charset="0"/>
                 <a:ea typeface="Calibri" pitchFamily="34" charset="-122"/>
@@ -10097,7 +9617,7 @@
             <a:r>
               <a:rPr lang="en-US" sz="1400" dirty="0">
                 <a:solidFill>
-                  <a:srgbClr val="1B1F23"/>
+                  <a:srgbClr val="17211C"/>
                 </a:solidFill>
                 <a:latin typeface="Calibri" pitchFamily="34" charset="0"/>
                 <a:ea typeface="Calibri" pitchFamily="34" charset="-122"/>
@@ -10124,7 +9644,7 @@
             <a:avLst/>
           </a:prstGeom>
           <a:solidFill>
-            <a:srgbClr val="C75A0B"/>
+            <a:srgbClr val="00873A"/>
           </a:solidFill>
           <a:ln w="25400">
             <a:solidFill>
@@ -10161,7 +9681,7 @@
             <a:r>
               <a:rPr lang="en-US" sz="2400" b="1" dirty="0">
                 <a:solidFill>
-                  <a:srgbClr val="C75A0B"/>
+                  <a:srgbClr val="00873A"/>
                 </a:solidFill>
                 <a:latin typeface="Cambria" pitchFamily="34" charset="0"/>
                 <a:ea typeface="Cambria" pitchFamily="34" charset="-122"/>
@@ -10200,7 +9720,7 @@
             <a:r>
               <a:rPr lang="en-US" sz="1400" dirty="0">
                 <a:solidFill>
-                  <a:srgbClr val="1B1F23"/>
+                  <a:srgbClr val="17211C"/>
                 </a:solidFill>
                 <a:latin typeface="Calibri" pitchFamily="34" charset="0"/>
                 <a:ea typeface="Calibri" pitchFamily="34" charset="-122"/>
@@ -10303,7 +9823,7 @@
             <a:r>
               <a:rPr lang="en-US" sz="1400" dirty="0">
                 <a:solidFill>
-                  <a:srgbClr val="1B1F23"/>
+                  <a:srgbClr val="17211C"/>
                 </a:solidFill>
                 <a:latin typeface="Calibri" pitchFamily="34" charset="0"/>
                 <a:ea typeface="Calibri" pitchFamily="34" charset="-122"/>
@@ -10330,7 +9850,7 @@
             <a:avLst/>
           </a:prstGeom>
           <a:solidFill>
-            <a:srgbClr val="1F6F6B"/>
+            <a:srgbClr val="0B5D3B"/>
           </a:solidFill>
           <a:ln w="25400">
             <a:solidFill>
@@ -10367,7 +9887,7 @@
             <a:r>
               <a:rPr lang="en-US" sz="2400" b="1" dirty="0">
                 <a:solidFill>
-                  <a:srgbClr val="1F6F6B"/>
+                  <a:srgbClr val="0B5D3B"/>
                 </a:solidFill>
                 <a:latin typeface="Cambria" pitchFamily="34" charset="0"/>
                 <a:ea typeface="Cambria" pitchFamily="34" charset="-122"/>
@@ -10406,7 +9926,7 @@
             <a:r>
               <a:rPr lang="en-US" sz="1400" dirty="0">
                 <a:solidFill>
-                  <a:srgbClr val="1B1F23"/>
+                  <a:srgbClr val="17211C"/>
                 </a:solidFill>
                 <a:latin typeface="Calibri" pitchFamily="34" charset="0"/>
                 <a:ea typeface="Calibri" pitchFamily="34" charset="-122"/>
@@ -10435,11 +9955,11 @@
             </a:avLst>
           </a:prstGeom>
           <a:solidFill>
-            <a:srgbClr val="EEF0F1"/>
+            <a:srgbClr val="EDF2EE"/>
           </a:solidFill>
           <a:ln w="12700">
             <a:solidFill>
-              <a:srgbClr val="EEF0F1"/>
+              <a:srgbClr val="EDF2EE"/>
             </a:solidFill>
             <a:prstDash val="solid"/>
           </a:ln>
@@ -10472,7 +9992,7 @@
             <a:r>
               <a:rPr lang="en-US" sz="1600" dirty="0">
                 <a:solidFill>
-                  <a:srgbClr val="1B1F23"/>
+                  <a:srgbClr val="17211C"/>
                 </a:solidFill>
                 <a:latin typeface="Calibri" pitchFamily="34" charset="0"/>
                 <a:ea typeface="Calibri" pitchFamily="34" charset="-122"/>
@@ -10586,7 +10106,7 @@
             <a:r>
               <a:rPr lang="en-US" sz="3200" b="1" dirty="0">
                 <a:solidFill>
-                  <a:srgbClr val="1B1F23"/>
+                  <a:srgbClr val="17211C"/>
                 </a:solidFill>
                 <a:latin typeface="Cambria" pitchFamily="34" charset="0"/>
                 <a:ea typeface="Cambria" pitchFamily="34" charset="-122"/>
@@ -10615,11 +10135,11 @@
             </a:avLst>
           </a:prstGeom>
           <a:solidFill>
-            <a:srgbClr val="EEF0F1"/>
+            <a:srgbClr val="EDF2EE"/>
           </a:solidFill>
           <a:ln w="12700">
             <a:solidFill>
-              <a:srgbClr val="EEF0F1"/>
+              <a:srgbClr val="EDF2EE"/>
             </a:solidFill>
             <a:prstDash val="solid"/>
           </a:ln>
@@ -10652,7 +10172,7 @@
             <a:r>
               <a:rPr lang="en-US" sz="2200" b="1" dirty="0">
                 <a:solidFill>
-                  <a:srgbClr val="1F6F6B"/>
+                  <a:srgbClr val="0B5D3B"/>
                 </a:solidFill>
                 <a:latin typeface="Cambria" pitchFamily="34" charset="0"/>
                 <a:ea typeface="Cambria" pitchFamily="34" charset="-122"/>
@@ -10695,7 +10215,7 @@
             <a:r>
               <a:rPr lang="en-US" sz="1600" dirty="0">
                 <a:solidFill>
-                  <a:srgbClr val="1B1F23"/>
+                  <a:srgbClr val="17211C"/>
                 </a:solidFill>
                 <a:latin typeface="Calibri" pitchFamily="34" charset="0"/>
                 <a:ea typeface="Calibri" pitchFamily="34" charset="-122"/>
@@ -10716,7 +10236,7 @@
             <a:r>
               <a:rPr lang="en-US" sz="1600" dirty="0">
                 <a:solidFill>
-                  <a:srgbClr val="1B1F23"/>
+                  <a:srgbClr val="17211C"/>
                 </a:solidFill>
                 <a:latin typeface="Calibri" pitchFamily="34" charset="0"/>
                 <a:ea typeface="Calibri" pitchFamily="34" charset="-122"/>
@@ -10737,7 +10257,7 @@
             <a:r>
               <a:rPr lang="en-US" sz="1600" dirty="0">
                 <a:solidFill>
-                  <a:srgbClr val="1B1F23"/>
+                  <a:srgbClr val="17211C"/>
                 </a:solidFill>
                 <a:latin typeface="Calibri" pitchFamily="34" charset="0"/>
                 <a:ea typeface="Calibri" pitchFamily="34" charset="-122"/>
@@ -10758,7 +10278,7 @@
             <a:r>
               <a:rPr lang="en-US" sz="1600" dirty="0">
                 <a:solidFill>
-                  <a:srgbClr val="1B1F23"/>
+                  <a:srgbClr val="17211C"/>
                 </a:solidFill>
                 <a:latin typeface="Calibri" pitchFamily="34" charset="0"/>
                 <a:ea typeface="Calibri" pitchFamily="34" charset="-122"/>
@@ -10787,11 +10307,11 @@
             </a:avLst>
           </a:prstGeom>
           <a:solidFill>
-            <a:srgbClr val="EEF0F1"/>
+            <a:srgbClr val="EDF2EE"/>
           </a:solidFill>
           <a:ln w="12700">
             <a:solidFill>
-              <a:srgbClr val="EEF0F1"/>
+              <a:srgbClr val="EDF2EE"/>
             </a:solidFill>
             <a:prstDash val="solid"/>
           </a:ln>
@@ -10867,7 +10387,7 @@
             <a:r>
               <a:rPr lang="en-US" sz="1600" dirty="0">
                 <a:solidFill>
-                  <a:srgbClr val="1B1F23"/>
+                  <a:srgbClr val="17211C"/>
                 </a:solidFill>
                 <a:latin typeface="Calibri" pitchFamily="34" charset="0"/>
                 <a:ea typeface="Calibri" pitchFamily="34" charset="-122"/>
@@ -10888,7 +10408,7 @@
             <a:r>
               <a:rPr lang="en-US" sz="1600" dirty="0">
                 <a:solidFill>
-                  <a:srgbClr val="1B1F23"/>
+                  <a:srgbClr val="17211C"/>
                 </a:solidFill>
                 <a:latin typeface="Calibri" pitchFamily="34" charset="0"/>
                 <a:ea typeface="Calibri" pitchFamily="34" charset="-122"/>
@@ -10909,7 +10429,7 @@
             <a:r>
               <a:rPr lang="en-US" sz="1600" dirty="0">
                 <a:solidFill>
-                  <a:srgbClr val="1B1F23"/>
+                  <a:srgbClr val="17211C"/>
                 </a:solidFill>
                 <a:latin typeface="Calibri" pitchFamily="34" charset="0"/>
                 <a:ea typeface="Calibri" pitchFamily="34" charset="-122"/>
@@ -10930,7 +10450,7 @@
             <a:r>
               <a:rPr lang="en-US" sz="1600" dirty="0">
                 <a:solidFill>
-                  <a:srgbClr val="1B1F23"/>
+                  <a:srgbClr val="17211C"/>
                 </a:solidFill>
                 <a:latin typeface="Calibri" pitchFamily="34" charset="0"/>
                 <a:ea typeface="Calibri" pitchFamily="34" charset="-122"/>
@@ -10959,11 +10479,11 @@
             </a:avLst>
           </a:prstGeom>
           <a:solidFill>
-            <a:srgbClr val="26333D"/>
+            <a:srgbClr val="0B3B2A"/>
           </a:solidFill>
           <a:ln w="12700">
             <a:solidFill>
-              <a:srgbClr val="26333D"/>
+              <a:srgbClr val="0B3B2A"/>
             </a:solidFill>
             <a:prstDash val="solid"/>
           </a:ln>
@@ -11110,7 +10630,7 @@
             <a:r>
               <a:rPr lang="en-US" sz="3200" b="1" dirty="0">
                 <a:solidFill>
-                  <a:srgbClr val="1B1F23"/>
+                  <a:srgbClr val="17211C"/>
                 </a:solidFill>
                 <a:latin typeface="Cambria" pitchFamily="34" charset="0"/>
                 <a:ea typeface="Cambria" pitchFamily="34" charset="-122"/>
@@ -11155,11 +10675,11 @@
             </a:avLst>
           </a:prstGeom>
           <a:solidFill>
-            <a:srgbClr val="EEF0F1"/>
+            <a:srgbClr val="EDF2EE"/>
           </a:solidFill>
           <a:ln w="12700">
             <a:solidFill>
-              <a:srgbClr val="EEF0F1"/>
+              <a:srgbClr val="EDF2EE"/>
             </a:solidFill>
             <a:prstDash val="solid"/>
           </a:ln>
@@ -11192,7 +10712,7 @@
             <a:r>
               <a:rPr lang="en-US" sz="3000" b="1" dirty="0">
                 <a:solidFill>
-                  <a:srgbClr val="C75A0B"/>
+                  <a:srgbClr val="00873A"/>
                 </a:solidFill>
                 <a:latin typeface="Cambria" pitchFamily="34" charset="0"/>
                 <a:ea typeface="Cambria" pitchFamily="34" charset="-122"/>
@@ -11209,7 +10729,7 @@
             <a:r>
               <a:rPr lang="en-US" sz="1600" dirty="0">
                 <a:solidFill>
-                  <a:srgbClr val="1B1F23"/>
+                  <a:srgbClr val="17211C"/>
                 </a:solidFill>
                 <a:latin typeface="Calibri" pitchFamily="34" charset="0"/>
                 <a:ea typeface="Calibri" pitchFamily="34" charset="-122"/>
@@ -11238,11 +10758,11 @@
             </a:avLst>
           </a:prstGeom>
           <a:solidFill>
-            <a:srgbClr val="EEF0F1"/>
+            <a:srgbClr val="EDF2EE"/>
           </a:solidFill>
           <a:ln w="12700">
             <a:solidFill>
-              <a:srgbClr val="EEF0F1"/>
+              <a:srgbClr val="EDF2EE"/>
             </a:solidFill>
             <a:prstDash val="solid"/>
           </a:ln>
@@ -11275,7 +10795,7 @@
             <a:r>
               <a:rPr lang="en-US" sz="3000" b="1" dirty="0">
                 <a:solidFill>
-                  <a:srgbClr val="C75A0B"/>
+                  <a:srgbClr val="00873A"/>
                 </a:solidFill>
                 <a:latin typeface="Cambria" pitchFamily="34" charset="0"/>
                 <a:ea typeface="Cambria" pitchFamily="34" charset="-122"/>
@@ -11292,7 +10812,7 @@
             <a:r>
               <a:rPr lang="en-US" sz="1600" dirty="0">
                 <a:solidFill>
-                  <a:srgbClr val="1B1F23"/>
+                  <a:srgbClr val="17211C"/>
                 </a:solidFill>
                 <a:latin typeface="Calibri" pitchFamily="34" charset="0"/>
                 <a:ea typeface="Calibri" pitchFamily="34" charset="-122"/>
@@ -11445,7 +10965,7 @@
             <a:r>
               <a:rPr lang="en-US" sz="3200" b="1" dirty="0">
                 <a:solidFill>
-                  <a:srgbClr val="1B1F23"/>
+                  <a:srgbClr val="17211C"/>
                 </a:solidFill>
                 <a:latin typeface="Cambria" pitchFamily="34" charset="0"/>
                 <a:ea typeface="Cambria" pitchFamily="34" charset="-122"/>
@@ -11504,7 +11024,7 @@
             <a:r>
               <a:rPr lang="en-US" sz="1600" dirty="0">
                 <a:solidFill>
-                  <a:srgbClr val="1B1F23"/>
+                  <a:srgbClr val="17211C"/>
                 </a:solidFill>
                 <a:latin typeface="Calibri" pitchFamily="34" charset="0"/>
                 <a:ea typeface="Calibri" pitchFamily="34" charset="-122"/>
@@ -11525,7 +11045,7 @@
             <a:r>
               <a:rPr lang="en-US" sz="1600" dirty="0">
                 <a:solidFill>
-                  <a:srgbClr val="1B1F23"/>
+                  <a:srgbClr val="17211C"/>
                 </a:solidFill>
                 <a:latin typeface="Calibri" pitchFamily="34" charset="0"/>
                 <a:ea typeface="Calibri" pitchFamily="34" charset="-122"/>
@@ -11546,7 +11066,7 @@
             <a:r>
               <a:rPr lang="en-US" sz="1600" dirty="0">
                 <a:solidFill>
-                  <a:srgbClr val="1B1F23"/>
+                  <a:srgbClr val="17211C"/>
                 </a:solidFill>
                 <a:latin typeface="Calibri" pitchFamily="34" charset="0"/>
                 <a:ea typeface="Calibri" pitchFamily="34" charset="-122"/>
@@ -11654,26 +11174,26 @@
 </file>
 
 <file path=ppt/theme/theme1.xml><?xml version="1.0" encoding="utf-8"?>
-<a:theme xmlns:a="http://schemas.openxmlformats.org/drawingml/2006/main" name="Diesel Hedge">
+<a:theme xmlns:a="http://schemas.openxmlformats.org/drawingml/2006/main" name="Vibra Diesel Hedge">
   <a:themeElements>
-    <a:clrScheme name="Diesel Hedge">
+    <a:clrScheme name="Vibra Diesel Hedge">
       <a:dk1>
-        <a:srgbClr val="1B1F23"/>
+        <a:srgbClr val="17211C"/>
       </a:dk1>
       <a:lt1>
         <a:srgbClr val="FFFFFF"/>
       </a:lt1>
       <a:dk2>
-        <a:srgbClr val="26333D"/>
+        <a:srgbClr val="0B3B2A"/>
       </a:dk2>
       <a:lt2>
-        <a:srgbClr val="EEF0F1"/>
+        <a:srgbClr val="EDF2EE"/>
       </a:lt2>
       <a:accent1>
-        <a:srgbClr val="C75A0B"/>
+        <a:srgbClr val="00873A"/>
       </a:accent1>
       <a:accent2>
-        <a:srgbClr val="1F6F6B"/>
+        <a:srgbClr val="0B5D3B"/>
       </a:accent2>
       <a:accent3>
         <a:srgbClr val="9B2D20"/>
@@ -11682,19 +11202,19 @@
         <a:srgbClr val="4A5A66"/>
       </a:accent4>
       <a:accent5>
-        <a:srgbClr val="E9B44C"/>
+        <a:srgbClr val="FFCB05"/>
       </a:accent5>
       <a:accent6>
-        <a:srgbClr val="2F855A"/>
+        <a:srgbClr val="00A859"/>
       </a:accent6>
       <a:hlink>
-        <a:srgbClr val="1F6F6B"/>
+        <a:srgbClr val="0B5D3B"/>
       </a:hlink>
       <a:folHlink>
         <a:srgbClr val="4A5A66"/>
       </a:folHlink>
     </a:clrScheme>
-    <a:fontScheme name="Diesel Hedge">
+    <a:fontScheme name="Vibra Diesel Hedge">
       <a:majorFont>
         <a:latin typeface="Cambria"/>
         <a:ea typeface=""/>

</xml_diff>